<commit_message>
Update the deck: problem statement, Crazyflie thrust, progress so far
- New slide 2: the problem statement as the brief gives it (any quadrotor),
  with the Crazyflie 2.1 as our stand-in for a custom-built airframe
- Slides 4-5: Bitcraze's rated 12.2 g per motor (thrust-to-weight 1.7-2.2,
  not 2.2-3.5) and the 1.8 : 1 needed to keep flying after the fault
- New slide 13: simulation results so far (Python sim and CrazySim)
- Tools: our own Python simulator and WLS solver (not PyBullet, Paparazzi)

Co-Authored-By: Claude Opus 5.5 <noreply@anthropic.com>
</commit_message>
<xml_diff>
--- a/Fault-Tolerant Quadrotor Control - Crazyflie.pptx
+++ b/Fault-Tolerant Quadrotor Control - Crazyflie.pptx
@@ -6,6 +6,7 @@
   </p:sldMasterIdLst>
   <p:sldIdLst>
     <p:sldId id="256" r:id="rId2"/>
+    <p:sldId id="271" r:id="rId22"/>
     <p:sldId id="257" r:id="rId3"/>
     <p:sldId id="258" r:id="rId4"/>
     <p:sldId id="259" r:id="rId5"/>
@@ -16,6 +17,7 @@
     <p:sldId id="264" r:id="rId10"/>
     <p:sldId id="265" r:id="rId11"/>
     <p:sldId id="266" r:id="rId12"/>
+    <p:sldId id="272" r:id="rId23"/>
     <p:sldId id="267" r:id="rId13"/>
     <p:sldId id="268" r:id="rId14"/>
     <p:sldId id="269" r:id="rId15"/>
@@ -2536,7 +2538,7 @@
                   <a:schemeClr val="tx2"/>
                 </a:solidFill>
               </a:rPr>
-              <a:t>A quadrotor that keeps flying its path when one motor drops to 50% RPM</a:t>
+              <a:t>A quadrotor that stays under control when one motor drops to 50% RPM mid-mission</a:t>
             </a:r>
             <a:endParaRPr lang="en-US" sz="1800" dirty="0"/>
           </a:p>
@@ -2572,7 +2574,7 @@
                   <a:schemeClr val="tx2"/>
                 </a:solidFill>
               </a:rPr>
-              <a:t>Platform: Crazyflie nano quadrotor</a:t>
+              <a:t>Demonstrated on a Crazyflie 2.1 nano quadrotor</a:t>
             </a:r>
             <a:endParaRPr lang="en-US" sz="1200" dirty="0"/>
           </a:p>
@@ -2686,6 +2688,10 @@
             <a:prstDash val="solid"/>
           </a:ln>
         </p:spPr>
+        <p:txBody>
+          <a:bodyPr/>
+          <a:p/>
+        </p:txBody>
       </p:sp>
       <p:sp>
         <p:nvSpPr>
@@ -2709,6 +2715,10 @@
             <a:prstDash val="solid"/>
           </a:ln>
         </p:spPr>
+        <p:txBody>
+          <a:bodyPr/>
+          <a:p/>
+        </p:txBody>
       </p:sp>
       <p:sp>
         <p:nvSpPr>
@@ -2736,6 +2746,10 @@
             <a:prstDash val="solid"/>
           </a:ln>
         </p:spPr>
+        <p:txBody>
+          <a:bodyPr/>
+          <a:p/>
+        </p:txBody>
       </p:sp>
       <p:sp>
         <p:nvSpPr>
@@ -2761,6 +2775,10 @@
             <a:prstDash val="solid"/>
           </a:ln>
         </p:spPr>
+        <p:txBody>
+          <a:bodyPr/>
+          <a:p/>
+        </p:txBody>
       </p:sp>
       <p:sp>
         <p:nvSpPr>
@@ -2786,6 +2804,10 @@
             <a:prstDash val="solid"/>
           </a:ln>
         </p:spPr>
+        <p:txBody>
+          <a:bodyPr/>
+          <a:p/>
+        </p:txBody>
       </p:sp>
       <p:sp>
         <p:nvSpPr>
@@ -2811,6 +2833,10 @@
             <a:prstDash val="solid"/>
           </a:ln>
         </p:spPr>
+        <p:txBody>
+          <a:bodyPr/>
+          <a:p/>
+        </p:txBody>
       </p:sp>
       <p:sp>
         <p:nvSpPr>
@@ -2836,6 +2862,10 @@
             <a:prstDash val="solid"/>
           </a:ln>
         </p:spPr>
+        <p:txBody>
+          <a:bodyPr/>
+          <a:p/>
+        </p:txBody>
       </p:sp>
       <p:sp>
         <p:nvSpPr>
@@ -3386,6 +3416,10 @@
           </a:solidFill>
           <a:ln/>
         </p:spPr>
+        <p:txBody>
+          <a:bodyPr/>
+          <a:p/>
+        </p:txBody>
       </p:sp>
       <p:sp>
         <p:nvSpPr>
@@ -3489,7 +3523,7 @@
                   <a:schemeClr val="tx2"/>
                 </a:solidFill>
               </a:rPr>
-              <a:t>PyBullet: prove the algorithm with one motor capped</a:t>
+              <a:t>Our Python simulator: prove the algorithm with one motor capped</a:t>
             </a:r>
             <a:endParaRPr lang="en-US" sz="1100" dirty="0"/>
           </a:p>
@@ -3518,6 +3552,10 @@
             <a:tailEnd type="triangle"/>
           </a:ln>
         </p:spPr>
+        <p:txBody>
+          <a:bodyPr/>
+          <a:p/>
+        </p:txBody>
       </p:sp>
       <p:sp>
         <p:nvSpPr>
@@ -3538,6 +3576,10 @@
           </a:solidFill>
           <a:ln/>
         </p:spPr>
+        <p:txBody>
+          <a:bodyPr/>
+          <a:p/>
+        </p:txBody>
       </p:sp>
       <p:sp>
         <p:nvSpPr>
@@ -3670,6 +3712,10 @@
             <a:tailEnd type="triangle"/>
           </a:ln>
         </p:spPr>
+        <p:txBody>
+          <a:bodyPr/>
+          <a:p/>
+        </p:txBody>
       </p:sp>
       <p:sp>
         <p:nvSpPr>
@@ -3690,6 +3736,10 @@
           </a:solidFill>
           <a:ln/>
         </p:spPr>
+        <p:txBody>
+          <a:bodyPr/>
+          <a:p/>
+        </p:txBody>
       </p:sp>
       <p:sp>
         <p:nvSpPr>
@@ -3822,6 +3872,10 @@
             <a:tailEnd type="triangle"/>
           </a:ln>
         </p:spPr>
+        <p:txBody>
+          <a:bodyPr/>
+          <a:p/>
+        </p:txBody>
       </p:sp>
       <p:sp>
         <p:nvSpPr>
@@ -3842,6 +3896,10 @@
           </a:solidFill>
           <a:ln/>
         </p:spPr>
+        <p:txBody>
+          <a:bodyPr/>
+          <a:p/>
+        </p:txBody>
       </p:sp>
       <p:sp>
         <p:nvSpPr>
@@ -3974,6 +4032,10 @@
             <a:tailEnd type="triangle"/>
           </a:ln>
         </p:spPr>
+        <p:txBody>
+          <a:bodyPr/>
+          <a:p/>
+        </p:txBody>
       </p:sp>
       <p:sp>
         <p:nvSpPr>
@@ -3994,6 +4056,10 @@
           </a:solidFill>
           <a:ln/>
         </p:spPr>
+        <p:txBody>
+          <a:bodyPr/>
+          <a:p/>
+        </p:txBody>
       </p:sp>
       <p:sp>
         <p:nvSpPr>
@@ -4163,6 +4229,10 @@
             <a:prstDash val="solid"/>
           </a:ln>
         </p:spPr>
+        <p:txBody>
+          <a:bodyPr/>
+          <a:p/>
+        </p:txBody>
       </p:sp>
       <p:sp>
         <p:nvSpPr>
@@ -4238,6 +4308,10 @@
             <a:prstDash val="solid"/>
           </a:ln>
         </p:spPr>
+        <p:txBody>
+          <a:bodyPr/>
+          <a:p/>
+        </p:txBody>
       </p:sp>
       <p:sp>
         <p:nvSpPr>
@@ -4313,6 +4387,10 @@
             <a:prstDash val="solid"/>
           </a:ln>
         </p:spPr>
+        <p:txBody>
+          <a:bodyPr/>
+          <a:p/>
+        </p:txBody>
       </p:sp>
       <p:sp>
         <p:nvSpPr>
@@ -6645,6 +6723,10 @@
           </a:solidFill>
           <a:ln/>
         </p:spPr>
+        <p:txBody>
+          <a:bodyPr/>
+          <a:p/>
+        </p:txBody>
       </p:sp>
       <p:sp>
         <p:nvSpPr>
@@ -6665,6 +6747,10 @@
           </a:solidFill>
           <a:ln/>
         </p:spPr>
+        <p:txBody>
+          <a:bodyPr/>
+          <a:p/>
+        </p:txBody>
       </p:sp>
       <p:sp>
         <p:nvSpPr>
@@ -6938,7 +7024,7 @@
                   <a:schemeClr val="tx1"/>
                 </a:solidFill>
               </a:rPr>
-              <a:t>Other faults: a fully stopped motor, sensor failures</a:t>
+              <a:t>Other faults: sensor failures; a fully stopped motor (simulation only)</a:t>
             </a:r>
             <a:endParaRPr lang="en-US" sz="1300" dirty="0"/>
           </a:p>
@@ -6968,6 +7054,10 @@
             <a:prstDash val="solid"/>
           </a:ln>
         </p:spPr>
+        <p:txBody>
+          <a:bodyPr/>
+          <a:p/>
+        </p:txBody>
       </p:sp>
       <p:sp>
         <p:nvSpPr>
@@ -7331,7 +7421,7 @@
                           <a:ea typeface="Calibri" pitchFamily="34" charset="-122"/>
                           <a:cs typeface="Calibri" pitchFamily="34" charset="-120"/>
                         </a:rPr>
-                        <a:t>Crazyflie nano quadrotor</a:t>
+                        <a:t>Crazyflie 2.1 nano quadrotor</a:t>
                       </a:r>
                       <a:endParaRPr lang="en-US" sz="1200" dirty="0">
                         <a:latin typeface="Calibri" charset="0"/>
@@ -7396,7 +7486,7 @@
                           <a:ea typeface="Calibri" pitchFamily="34" charset="-122"/>
                           <a:cs typeface="Calibri" pitchFamily="34" charset="-120"/>
                         </a:rPr>
-                        <a:t>Our drone (from the lab); runs our control code</a:t>
+                        <a:t>Stands in for a custom-built quadrotor (from the lab); runs our control code</a:t>
                       </a:r>
                       <a:endParaRPr lang="en-US" sz="1200" dirty="0">
                         <a:latin typeface="Calibri" charset="0"/>
@@ -8459,7 +8549,7 @@
                           <a:ea typeface="Calibri" pitchFamily="34" charset="-122"/>
                           <a:cs typeface="Calibri" pitchFamily="34" charset="-120"/>
                         </a:rPr>
-                        <a:t>Paparazzi WLS solver</a:t>
+                        <a:t>Our WLS solver (C)</a:t>
                       </a:r>
                       <a:endParaRPr lang="en-US" sz="1200" dirty="0">
                         <a:latin typeface="Calibri" charset="0"/>
@@ -8524,7 +8614,7 @@
                           <a:ea typeface="Calibri" pitchFamily="34" charset="-122"/>
                           <a:cs typeface="Calibri" pitchFamily="34" charset="-120"/>
                         </a:rPr>
-                        <a:t>Open-source WLS code we reuse for motor sharing</a:t>
+                        <a:t>Motor sharing; checked against our Python version</a:t>
                       </a:r>
                       <a:endParaRPr lang="en-US" sz="1200" dirty="0">
                         <a:latin typeface="Calibri" charset="0"/>
@@ -8591,7 +8681,7 @@
                           <a:ea typeface="Calibri" pitchFamily="34" charset="-122"/>
                           <a:cs typeface="Calibri" pitchFamily="34" charset="-120"/>
                         </a:rPr>
-                        <a:t>PyBullet, CrazySim</a:t>
+                        <a:t>Our Python simulator, CrazySim</a:t>
                       </a:r>
                       <a:endParaRPr lang="en-US" sz="1200" dirty="0">
                         <a:latin typeface="Calibri" charset="0"/>
@@ -8919,7 +9009,7 @@
                   <a:schemeClr val="tx1"/>
                 </a:solidFill>
               </a:rPr>
-              <a:t>One motor at 50% RPM leaves 25% of its thrust. A small quadrotor can't then stay level and hold its heading.</a:t>
+              <a:t>Keep a quadrotor under control on an autonomous mission when one motor drops to 50% RPM (25% of its thrust), then continue the mission or land safely.</a:t>
             </a:r>
             <a:endParaRPr lang="en-US" sz="1600" dirty="0"/>
           </a:p>
@@ -9063,7 +9153,7 @@
                   <a:schemeClr val="tx1"/>
                 </a:solidFill>
               </a:rPr>
-              <a:t>One rectangle on a football ground: a baseline flight, then a fault flight that finishes or lands safely.</a:t>
+              <a:t>One rectangle on a football ground with a Crazyflie 2.1: a baseline flight, then a fault flight that finishes or lands safely.</a:t>
             </a:r>
             <a:endParaRPr lang="en-US" sz="1600" dirty="0"/>
           </a:p>
@@ -9145,6 +9235,2191 @@
             <a:fld id="{F7021451-1387-4CA6-816F-3879F97B5CBC}" type="slidenum">
               <a:rPr b="0" lang="en-US"/>
               <a:t>15</a:t>
+            </a:fld>
+            <a:endParaRPr lang="en-US"/>
+          </a:p>
+        </p:txBody>
+      </p:sp>
+    </p:spTree>
+  </p:cSld>
+  <p:clrMapOvr>
+    <a:masterClrMapping/>
+  </p:clrMapOvr>
+</p:sld>
+</file>
+
+<file path=ppt/slides/slide16.xml><?xml version="1.0" encoding="utf-8"?>
+<p:sld xmlns:a="http://schemas.openxmlformats.org/drawingml/2006/main" xmlns:p="http://schemas.openxmlformats.org/presentationml/2006/main" xmlns:r="http://schemas.openxmlformats.org/officeDocument/2006/relationships">
+  <p:cSld>
+    <p:spTree>
+      <p:nvGrpSpPr>
+        <p:cNvPr id="1" name=""/>
+        <p:cNvGrpSpPr/>
+        <p:nvPr/>
+      </p:nvGrpSpPr>
+      <p:grpSpPr/>
+      <p:sp>
+        <p:nvSpPr>
+          <p:cNvPr id="2" name="Text 0"/>
+          <p:cNvSpPr/>
+          <p:nvPr>
+            <p:ph idx="100" type="title" hasCustomPrompt="1"/>
+          </p:nvPr>
+        </p:nvSpPr>
+        <p:spPr>
+          <a:xfrm>
+            <a:off x="457200" y="274320"/>
+            <a:ext cx="8229600" cy="594360"/>
+          </a:xfrm>
+          <a:prstGeom prst="rect">
+            <a:avLst/>
+          </a:prstGeom>
+          <a:noFill/>
+          <a:ln/>
+        </p:spPr>
+        <p:txBody>
+          <a:bodyPr wrap="square" lIns="0" tIns="0" rIns="0" bIns="0" rtlCol="0" anchor="ctr"/>
+          <a:lstStyle/>
+          <a:p>
+            <a:pPr algn="l" indent="0" marL="0">
+              <a:buNone/>
+            </a:pPr>
+            <a:r>
+              <a:rPr lang="en-US" sz="2800" b="1" dirty="0">
+                <a:solidFill>
+                  <a:schemeClr val="tx1"/>
+                </a:solidFill>
+              </a:rPr>
+              <a:t>Problem statement</a:t>
+            </a:r>
+            <a:endParaRPr lang="en-US" sz="2800" dirty="0"/>
+          </a:p>
+        </p:txBody>
+      </p:sp>
+      <p:sp>
+        <p:nvSpPr>
+          <p:cNvPr id="3" name="Text 1"/>
+          <p:cNvSpPr txBox="1"/>
+          <p:nvPr/>
+        </p:nvSpPr>
+        <p:spPr>
+          <a:xfrm>
+            <a:off x="457200" y="1097280"/>
+            <a:ext cx="365760" cy="548640"/>
+          </a:xfrm>
+          <a:prstGeom prst="rect">
+            <a:avLst/>
+          </a:prstGeom>
+          <a:noFill/>
+          <a:ln/>
+        </p:spPr>
+        <p:txBody>
+          <a:bodyPr wrap="square" lIns="0" tIns="0" rIns="0" bIns="0" rtlCol="0" anchor="t"/>
+          <a:lstStyle/>
+          <a:p>
+            <a:pPr indent="0" marL="0">
+              <a:buNone/>
+            </a:pPr>
+            <a:r>
+              <a:rPr lang="en-US" sz="2200" b="1" dirty="0">
+                <a:solidFill>
+                  <a:schemeClr val="accent1"/>
+                </a:solidFill>
+              </a:rPr>
+              <a:t>1</a:t>
+            </a:r>
+            <a:endParaRPr lang="en-US" sz="2200" dirty="0"/>
+          </a:p>
+        </p:txBody>
+      </p:sp>
+      <p:sp>
+        <p:nvSpPr>
+          <p:cNvPr id="4" name="Text 2"/>
+          <p:cNvSpPr txBox="1"/>
+          <p:nvPr/>
+        </p:nvSpPr>
+        <p:spPr>
+          <a:xfrm>
+            <a:off x="868680" y="1143000"/>
+            <a:ext cx="4572000" cy="548640"/>
+          </a:xfrm>
+          <a:prstGeom prst="rect">
+            <a:avLst/>
+          </a:prstGeom>
+          <a:noFill/>
+          <a:ln/>
+        </p:spPr>
+        <p:txBody>
+          <a:bodyPr wrap="square" lIns="0" tIns="0" rIns="0" bIns="0" rtlCol="0" anchor="t"/>
+          <a:lstStyle/>
+          <a:p>
+            <a:pPr indent="0" marL="0">
+              <a:buNone/>
+            </a:pPr>
+            <a:r>
+              <a:rPr lang="en-US" sz="1500" dirty="0">
+                <a:solidFill>
+                  <a:schemeClr val="tx1"/>
+                </a:solidFill>
+              </a:rPr>
+              <a:t>Design and build a quadrotor that stays under control after a partial loss of motor performance</a:t>
+            </a:r>
+            <a:endParaRPr lang="en-US" sz="1500" dirty="0"/>
+          </a:p>
+        </p:txBody>
+      </p:sp>
+      <p:sp>
+        <p:nvSpPr>
+          <p:cNvPr id="5" name="Text 3"/>
+          <p:cNvSpPr txBox="1"/>
+          <p:nvPr/>
+        </p:nvSpPr>
+        <p:spPr>
+          <a:xfrm>
+            <a:off x="457200" y="1783080"/>
+            <a:ext cx="365760" cy="548640"/>
+          </a:xfrm>
+          <a:prstGeom prst="rect">
+            <a:avLst/>
+          </a:prstGeom>
+          <a:noFill/>
+          <a:ln/>
+        </p:spPr>
+        <p:txBody>
+          <a:bodyPr wrap="square" lIns="0" tIns="0" rIns="0" bIns="0" rtlCol="0" anchor="t"/>
+          <a:lstStyle/>
+          <a:p>
+            <a:pPr indent="0" marL="0">
+              <a:buNone/>
+            </a:pPr>
+            <a:r>
+              <a:rPr lang="en-US" sz="2200" b="1" dirty="0">
+                <a:solidFill>
+                  <a:schemeClr val="accent1"/>
+                </a:solidFill>
+              </a:rPr>
+              <a:t>2</a:t>
+            </a:r>
+            <a:endParaRPr lang="en-US" sz="2200" dirty="0"/>
+          </a:p>
+        </p:txBody>
+      </p:sp>
+      <p:sp>
+        <p:nvSpPr>
+          <p:cNvPr id="6" name="Text 4"/>
+          <p:cNvSpPr txBox="1"/>
+          <p:nvPr/>
+        </p:nvSpPr>
+        <p:spPr>
+          <a:xfrm>
+            <a:off x="868680" y="1828800"/>
+            <a:ext cx="4572000" cy="548640"/>
+          </a:xfrm>
+          <a:prstGeom prst="rect">
+            <a:avLst/>
+          </a:prstGeom>
+          <a:noFill/>
+          <a:ln/>
+        </p:spPr>
+        <p:txBody>
+          <a:bodyPr wrap="square" lIns="0" tIns="0" rIns="0" bIns="0" rtlCol="0" anchor="t"/>
+          <a:lstStyle/>
+          <a:p>
+            <a:pPr indent="0" marL="0">
+              <a:buNone/>
+            </a:pPr>
+            <a:r>
+              <a:rPr lang="en-US" sz="1500" dirty="0">
+                <a:solidFill>
+                  <a:schemeClr val="tx1"/>
+                </a:solidFill>
+              </a:rPr>
+              <a:t>During an autonomous waypoint mission, one motor is limited externally to 50% of its maximum RPM</a:t>
+            </a:r>
+            <a:endParaRPr lang="en-US" sz="1500" dirty="0"/>
+          </a:p>
+        </p:txBody>
+      </p:sp>
+      <p:sp>
+        <p:nvSpPr>
+          <p:cNvPr id="7" name="Text 5"/>
+          <p:cNvSpPr txBox="1"/>
+          <p:nvPr/>
+        </p:nvSpPr>
+        <p:spPr>
+          <a:xfrm>
+            <a:off x="457200" y="2468880"/>
+            <a:ext cx="365760" cy="548640"/>
+          </a:xfrm>
+          <a:prstGeom prst="rect">
+            <a:avLst/>
+          </a:prstGeom>
+          <a:noFill/>
+          <a:ln/>
+        </p:spPr>
+        <p:txBody>
+          <a:bodyPr wrap="square" lIns="0" tIns="0" rIns="0" bIns="0" rtlCol="0" anchor="t"/>
+          <a:lstStyle/>
+          <a:p>
+            <a:pPr indent="0" marL="0">
+              <a:buNone/>
+            </a:pPr>
+            <a:r>
+              <a:rPr lang="en-US" sz="2200" b="1" dirty="0">
+                <a:solidFill>
+                  <a:schemeClr val="accent1"/>
+                </a:solidFill>
+              </a:rPr>
+              <a:t>3</a:t>
+            </a:r>
+            <a:endParaRPr lang="en-US" sz="2200" dirty="0"/>
+          </a:p>
+        </p:txBody>
+      </p:sp>
+      <p:sp>
+        <p:nvSpPr>
+          <p:cNvPr id="8" name="Text 6"/>
+          <p:cNvSpPr txBox="1"/>
+          <p:nvPr/>
+        </p:nvSpPr>
+        <p:spPr>
+          <a:xfrm>
+            <a:off x="868680" y="2514600"/>
+            <a:ext cx="4572000" cy="548640"/>
+          </a:xfrm>
+          <a:prstGeom prst="rect">
+            <a:avLst/>
+          </a:prstGeom>
+          <a:noFill/>
+          <a:ln/>
+        </p:spPr>
+        <p:txBody>
+          <a:bodyPr wrap="square" lIns="0" tIns="0" rIns="0" bIns="0" rtlCol="0" anchor="t"/>
+          <a:lstStyle/>
+          <a:p>
+            <a:pPr indent="0" marL="0">
+              <a:buNone/>
+            </a:pPr>
+            <a:r>
+              <a:rPr lang="en-US" sz="1500" dirty="0">
+                <a:solidFill>
+                  <a:schemeClr val="tx1"/>
+                </a:solidFill>
+              </a:rPr>
+              <a:t>The controller is told which motor: fault detection is not required</a:t>
+            </a:r>
+            <a:endParaRPr lang="en-US" sz="1500" dirty="0"/>
+          </a:p>
+        </p:txBody>
+      </p:sp>
+      <p:sp>
+        <p:nvSpPr>
+          <p:cNvPr id="9" name="Text 7"/>
+          <p:cNvSpPr txBox="1"/>
+          <p:nvPr/>
+        </p:nvSpPr>
+        <p:spPr>
+          <a:xfrm>
+            <a:off x="457200" y="3154680"/>
+            <a:ext cx="365760" cy="548640"/>
+          </a:xfrm>
+          <a:prstGeom prst="rect">
+            <a:avLst/>
+          </a:prstGeom>
+          <a:noFill/>
+          <a:ln/>
+        </p:spPr>
+        <p:txBody>
+          <a:bodyPr wrap="square" lIns="0" tIns="0" rIns="0" bIns="0" rtlCol="0" anchor="t"/>
+          <a:lstStyle/>
+          <a:p>
+            <a:pPr indent="0" marL="0">
+              <a:buNone/>
+            </a:pPr>
+            <a:r>
+              <a:rPr lang="en-US" sz="2200" b="1" dirty="0">
+                <a:solidFill>
+                  <a:schemeClr val="accent1"/>
+                </a:solidFill>
+              </a:rPr>
+              <a:t>4</a:t>
+            </a:r>
+            <a:endParaRPr lang="en-US" sz="2200" dirty="0"/>
+          </a:p>
+        </p:txBody>
+      </p:sp>
+      <p:sp>
+        <p:nvSpPr>
+          <p:cNvPr id="10" name="Text 8"/>
+          <p:cNvSpPr txBox="1"/>
+          <p:nvPr/>
+        </p:nvSpPr>
+        <p:spPr>
+          <a:xfrm>
+            <a:off x="868680" y="3200400"/>
+            <a:ext cx="4572000" cy="548640"/>
+          </a:xfrm>
+          <a:prstGeom prst="rect">
+            <a:avLst/>
+          </a:prstGeom>
+          <a:noFill/>
+          <a:ln/>
+        </p:spPr>
+        <p:txBody>
+          <a:bodyPr wrap="square" lIns="0" tIns="0" rIns="0" bIns="0" rtlCol="0" anchor="t"/>
+          <a:lstStyle/>
+          <a:p>
+            <a:pPr indent="0" marL="0">
+              <a:buNone/>
+            </a:pPr>
+            <a:r>
+              <a:rPr lang="en-US" sz="1500" dirty="0">
+                <a:solidFill>
+                  <a:schemeClr val="tx1"/>
+                </a:solidFill>
+              </a:rPr>
+              <a:t>The controller must adapt to the reduced actuator capability</a:t>
+            </a:r>
+            <a:endParaRPr lang="en-US" sz="1500" dirty="0"/>
+          </a:p>
+        </p:txBody>
+      </p:sp>
+      <p:sp>
+        <p:nvSpPr>
+          <p:cNvPr id="11" name="Text 9"/>
+          <p:cNvSpPr txBox="1"/>
+          <p:nvPr/>
+        </p:nvSpPr>
+        <p:spPr>
+          <a:xfrm>
+            <a:off x="457200" y="3840480"/>
+            <a:ext cx="365760" cy="548640"/>
+          </a:xfrm>
+          <a:prstGeom prst="rect">
+            <a:avLst/>
+          </a:prstGeom>
+          <a:noFill/>
+          <a:ln/>
+        </p:spPr>
+        <p:txBody>
+          <a:bodyPr wrap="square" lIns="0" tIns="0" rIns="0" bIns="0" rtlCol="0" anchor="t"/>
+          <a:lstStyle/>
+          <a:p>
+            <a:pPr indent="0" marL="0">
+              <a:buNone/>
+            </a:pPr>
+            <a:r>
+              <a:rPr lang="en-US" sz="2200" b="1" dirty="0">
+                <a:solidFill>
+                  <a:schemeClr val="accent1"/>
+                </a:solidFill>
+              </a:rPr>
+              <a:t>5</a:t>
+            </a:r>
+            <a:endParaRPr lang="en-US" sz="2200" dirty="0"/>
+          </a:p>
+        </p:txBody>
+      </p:sp>
+      <p:sp>
+        <p:nvSpPr>
+          <p:cNvPr id="12" name="Text 10"/>
+          <p:cNvSpPr txBox="1"/>
+          <p:nvPr/>
+        </p:nvSpPr>
+        <p:spPr>
+          <a:xfrm>
+            <a:off x="868680" y="3886200"/>
+            <a:ext cx="4572000" cy="548640"/>
+          </a:xfrm>
+          <a:prstGeom prst="rect">
+            <a:avLst/>
+          </a:prstGeom>
+          <a:noFill/>
+          <a:ln/>
+        </p:spPr>
+        <p:txBody>
+          <a:bodyPr wrap="square" lIns="0" tIns="0" rIns="0" bIns="0" rtlCol="0" anchor="t"/>
+          <a:lstStyle/>
+          <a:p>
+            <a:pPr indent="0" marL="0">
+              <a:buNone/>
+            </a:pPr>
+            <a:r>
+              <a:rPr lang="en-US" sz="1500" dirty="0">
+                <a:solidFill>
+                  <a:schemeClr val="tx1"/>
+                </a:solidFill>
+              </a:rPr>
+              <a:t>It then continues the mission, or ends it safely and lands, under control throughout</a:t>
+            </a:r>
+            <a:endParaRPr lang="en-US" sz="1500" dirty="0"/>
+          </a:p>
+        </p:txBody>
+      </p:sp>
+      <p:sp>
+        <p:nvSpPr>
+          <p:cNvPr id="13" name="Shape 11"/>
+          <p:cNvSpPr/>
+          <p:nvPr/>
+        </p:nvSpPr>
+        <p:spPr>
+          <a:xfrm>
+            <a:off x="5806440" y="1097280"/>
+            <a:ext cx="2880360" cy="3291840"/>
+          </a:xfrm>
+          <a:prstGeom prst="rect">
+            <a:avLst/>
+          </a:prstGeom>
+          <a:solidFill>
+            <a:schemeClr val="bg2"/>
+          </a:solidFill>
+          <a:ln/>
+        </p:spPr>
+        <p:txBody>
+          <a:bodyPr/>
+          <a:p/>
+        </p:txBody>
+      </p:sp>
+      <p:sp>
+        <p:nvSpPr>
+          <p:cNvPr id="14" name="Text 12"/>
+          <p:cNvSpPr txBox="1"/>
+          <p:nvPr/>
+        </p:nvSpPr>
+        <p:spPr>
+          <a:xfrm>
+            <a:off x="6035040" y="1280160"/>
+            <a:ext cx="2468880" cy="274320"/>
+          </a:xfrm>
+          <a:prstGeom prst="rect">
+            <a:avLst/>
+          </a:prstGeom>
+          <a:noFill/>
+          <a:ln/>
+        </p:spPr>
+        <p:txBody>
+          <a:bodyPr wrap="square" lIns="0" tIns="0" rIns="0" bIns="0" rtlCol="0" anchor="t"/>
+          <a:lstStyle/>
+          <a:p>
+            <a:pPr indent="0" marL="0">
+              <a:buNone/>
+            </a:pPr>
+            <a:r>
+              <a:rPr lang="en-US" sz="1500" b="1" dirty="0">
+                <a:solidFill>
+                  <a:schemeClr val="tx1"/>
+                </a:solidFill>
+              </a:rPr>
+              <a:t>Our platform</a:t>
+            </a:r>
+            <a:endParaRPr lang="en-US" sz="1500" dirty="0"/>
+          </a:p>
+        </p:txBody>
+      </p:sp>
+      <p:sp>
+        <p:nvSpPr>
+          <p:cNvPr id="15" name="Text 13"/>
+          <p:cNvSpPr txBox="1"/>
+          <p:nvPr/>
+        </p:nvSpPr>
+        <p:spPr>
+          <a:xfrm>
+            <a:off x="6035040" y="1600200"/>
+            <a:ext cx="2468880" cy="731520"/>
+          </a:xfrm>
+          <a:prstGeom prst="rect">
+            <a:avLst/>
+          </a:prstGeom>
+          <a:noFill/>
+          <a:ln/>
+        </p:spPr>
+        <p:txBody>
+          <a:bodyPr wrap="square" lIns="0" tIns="0" rIns="0" bIns="0" rtlCol="0" anchor="t"/>
+          <a:lstStyle/>
+          <a:p>
+            <a:pPr indent="0" marL="0">
+              <a:buNone/>
+            </a:pPr>
+            <a:r>
+              <a:rPr lang="en-US" sz="1400" dirty="0">
+                <a:solidFill>
+                  <a:schemeClr val="tx2"/>
+                </a:solidFill>
+              </a:rPr>
+              <a:t>We cannot build a quadrotor within the project time, so we fly a Crazyflie 2.1 (27 g, open firmware) as the airframe.</a:t>
+            </a:r>
+            <a:endParaRPr lang="en-US" sz="1400" dirty="0"/>
+          </a:p>
+        </p:txBody>
+      </p:sp>
+      <p:sp>
+        <p:nvSpPr>
+          <p:cNvPr id="16" name="Text 14"/>
+          <p:cNvSpPr txBox="1"/>
+          <p:nvPr/>
+        </p:nvSpPr>
+        <p:spPr>
+          <a:xfrm>
+            <a:off x="6035040" y="2606040"/>
+            <a:ext cx="2468880" cy="274320"/>
+          </a:xfrm>
+          <a:prstGeom prst="rect">
+            <a:avLst/>
+          </a:prstGeom>
+          <a:noFill/>
+          <a:ln/>
+        </p:spPr>
+        <p:txBody>
+          <a:bodyPr wrap="square" lIns="0" tIns="0" rIns="0" bIns="0" rtlCol="0" anchor="t"/>
+          <a:lstStyle/>
+          <a:p>
+            <a:pPr indent="0" marL="0">
+              <a:buNone/>
+            </a:pPr>
+            <a:r>
+              <a:rPr lang="en-US" sz="1500" b="1" dirty="0">
+                <a:solidFill>
+                  <a:schemeClr val="tx1"/>
+                </a:solidFill>
+              </a:rPr>
+              <a:t>What is ours</a:t>
+            </a:r>
+            <a:endParaRPr lang="en-US" sz="1500" dirty="0"/>
+          </a:p>
+        </p:txBody>
+      </p:sp>
+      <p:sp>
+        <p:nvSpPr>
+          <p:cNvPr id="17" name="Text 15"/>
+          <p:cNvSpPr txBox="1"/>
+          <p:nvPr/>
+        </p:nvSpPr>
+        <p:spPr>
+          <a:xfrm>
+            <a:off x="6035040" y="2926080"/>
+            <a:ext cx="2468880" cy="1097280"/>
+          </a:xfrm>
+          <a:prstGeom prst="rect">
+            <a:avLst/>
+          </a:prstGeom>
+          <a:noFill/>
+          <a:ln/>
+        </p:spPr>
+        <p:txBody>
+          <a:bodyPr wrap="square" lIns="0" tIns="0" rIns="0" bIns="0" rtlCol="0" anchor="t"/>
+          <a:lstStyle/>
+          <a:p>
+            <a:pPr indent="0" marL="0">
+              <a:buNone/>
+            </a:pPr>
+            <a:r>
+              <a:rPr lang="en-US" sz="1400" dirty="0">
+                <a:solidFill>
+                  <a:schemeClr val="tx2"/>
+                </a:solidFill>
+              </a:rPr>
+              <a:t>The fault-tolerant controller, the fault interface and the mission logic. None of them depend on the airframe.</a:t>
+            </a:r>
+            <a:endParaRPr lang="en-US" sz="1400" dirty="0"/>
+          </a:p>
+        </p:txBody>
+      </p:sp>
+      <p:sp>
+        <p:nvSpPr>
+          <p:cNvPr id="25" name="Slide Number Placeholder 0"/>
+          <p:cNvSpPr>
+            <a:spLocks noGrp="1"/>
+          </p:cNvSpPr>
+          <p:nvPr>
+            <p:ph type="sldNum" sz="quarter" idx="4294967295"/>
+          </p:nvPr>
+        </p:nvSpPr>
+        <p:spPr>
+          <a:xfrm>
+            <a:off x="8229600" y="4754880"/>
+            <a:ext cx="457200" cy="228600"/>
+          </a:xfrm>
+          <a:prstGeom prst="rect">
+            <a:avLst/>
+          </a:prstGeom>
+          <a:extLst>
+            <a:ext uri="{C572A759-6A51-4108-AA02-DFA0A04FC94B}">
+              <ma14:wrappingTextBoxFlag xmlns:ma14="http://schemas.microsoft.com/office/mac/drawingml/2011/main" val="0"/>
+            </a:ext>
+          </a:extLst>
+        </p:spPr>
+        <p:txBody>
+          <a:bodyPr/>
+          <a:lstStyle>
+            <a:lvl1pPr>
+              <a:defRPr sz="900">
+                <a:solidFill>
+                  <a:schemeClr val="tx2"/>
+                </a:solidFill>
+              </a:defRPr>
+            </a:lvl1pPr>
+          </a:lstStyle>
+          <a:p>
+            <a:pPr algn="r"/>
+            <a:fld id="{F7021451-1387-4CA6-816F-3879F97B5CBC}" type="slidenum">
+              <a:rPr b="0" lang="en-US"/>
+              <a:t>2</a:t>
+            </a:fld>
+            <a:endParaRPr lang="en-US"/>
+          </a:p>
+        </p:txBody>
+      </p:sp>
+    </p:spTree>
+  </p:cSld>
+  <p:clrMapOvr>
+    <a:masterClrMapping/>
+  </p:clrMapOvr>
+</p:sld>
+</file>
+
+<file path=ppt/slides/slide17.xml><?xml version="1.0" encoding="utf-8"?>
+<p:sld xmlns:a="http://schemas.openxmlformats.org/drawingml/2006/main" xmlns:p="http://schemas.openxmlformats.org/presentationml/2006/main" xmlns:r="http://schemas.openxmlformats.org/officeDocument/2006/relationships">
+  <p:cSld>
+    <p:spTree>
+      <p:nvGrpSpPr>
+        <p:cNvPr id="1" name=""/>
+        <p:cNvGrpSpPr/>
+        <p:nvPr/>
+      </p:nvGrpSpPr>
+      <p:grpSpPr/>
+      <p:sp>
+        <p:nvSpPr>
+          <p:cNvPr id="2" name="Text 0"/>
+          <p:cNvSpPr/>
+          <p:nvPr>
+            <p:ph idx="100" type="title" hasCustomPrompt="1"/>
+          </p:nvPr>
+        </p:nvSpPr>
+        <p:spPr>
+          <a:xfrm>
+            <a:off x="457200" y="274320"/>
+            <a:ext cx="8229600" cy="594360"/>
+          </a:xfrm>
+          <a:prstGeom prst="rect">
+            <a:avLst/>
+          </a:prstGeom>
+          <a:noFill/>
+          <a:ln/>
+        </p:spPr>
+        <p:txBody>
+          <a:bodyPr wrap="square" lIns="0" tIns="0" rIns="0" bIns="0" rtlCol="0" anchor="ctr"/>
+          <a:lstStyle/>
+          <a:p>
+            <a:pPr algn="l" indent="0" marL="0">
+              <a:buNone/>
+            </a:pPr>
+            <a:r>
+              <a:rPr lang="en-US" sz="2800" b="1" dirty="0">
+                <a:solidFill>
+                  <a:schemeClr val="tx1"/>
+                </a:solidFill>
+              </a:rPr>
+              <a:t>Progress so far (simulation)</a:t>
+            </a:r>
+            <a:endParaRPr lang="en-US" sz="2800" dirty="0"/>
+          </a:p>
+        </p:txBody>
+      </p:sp>
+      <p:graphicFrame>
+        <p:nvGraphicFramePr>
+          <p:cNvPr id="13" name="Table 0"/>
+          <p:cNvGraphicFramePr>
+            <a:graphicFrameLocks noGrp="1"/>
+          </p:cNvGraphicFramePr>
+          <p:nvPr>
+            <p:extLst>
+              <p:ext uri="{D42A27DB-BD31-4B8C-83A1-F6EECF244321}">
+                <p14:modId xmlns:p14="http://schemas.microsoft.com/office/powerpoint/2010/main" val="1579011935"/>
+              </p:ext>
+            </p:extLst>
+          </p:nvPr>
+        </p:nvGraphicFramePr>
+        <p:xfrm>
+          <a:off x="457200" y="914400"/>
+          <a:ext cx="8229600" cy="914400"/>
+        </p:xfrm>
+        <a:graphic>
+          <a:graphicData uri="http://schemas.openxmlformats.org/drawingml/2006/table">
+            <a:tbl>
+              <a:tblPr/>
+              <a:tblGrid>
+                <a:gridCol w="1097280"/>
+                <a:gridCol w="3108960"/>
+                <a:gridCol w="4023360"/>
+              </a:tblGrid>
+              <a:tr h="320040">
+                <a:tc>
+                  <a:txBody>
+                    <a:bodyPr/>
+                    <a:lstStyle/>
+                    <a:p>
+                      <a:pPr indent="0" marL="0">
+                        <a:buNone/>
+                      </a:pPr>
+                      <a:r>
+                        <a:rPr lang="en-US" sz="1200" b="1" dirty="0">
+                          <a:solidFill>
+                            <a:srgbClr val="1F2933"/>
+                          </a:solidFill>
+                          <a:latin typeface="Calibri" pitchFamily="34" charset="0"/>
+                          <a:ea typeface="Calibri" pitchFamily="34" charset="-122"/>
+                          <a:cs typeface="Calibri" pitchFamily="34" charset="-120"/>
+                        </a:rPr>
+                        <a:t>Where</a:t>
+                      </a:r>
+                      <a:endParaRPr lang="en-US" sz="1200" dirty="0">
+                        <a:latin typeface="Calibri" charset="0"/>
+                        <a:ea typeface="Calibri" charset="0"/>
+                        <a:cs typeface="Calibri" charset="0"/>
+                      </a:endParaRPr>
+                    </a:p>
+                  </a:txBody>
+                  <a:tcPr marL="76200" marR="76200" marT="38100" marB="38100" anchor="ctr">
+                    <a:lnL w="9525" cap="flat" cmpd="sng" algn="ctr">
+                      <a:solidFill>
+                        <a:srgbClr val="C9D0D7"/>
+                      </a:solidFill>
+                      <a:prstDash val="solid"/>
+                      <a:round/>
+                      <a:headEnd type="none" w="med" len="med"/>
+                      <a:tailEnd type="none" w="med" len="med"/>
+                    </a:lnL>
+                    <a:lnR w="9525" cap="flat" cmpd="sng" algn="ctr">
+                      <a:solidFill>
+                        <a:srgbClr val="C9D0D7"/>
+                      </a:solidFill>
+                      <a:prstDash val="solid"/>
+                      <a:round/>
+                      <a:headEnd type="none" w="med" len="med"/>
+                      <a:tailEnd type="none" w="med" len="med"/>
+                    </a:lnR>
+                    <a:lnT w="9525" cap="flat" cmpd="sng" algn="ctr">
+                      <a:solidFill>
+                        <a:srgbClr val="C9D0D7"/>
+                      </a:solidFill>
+                      <a:prstDash val="solid"/>
+                      <a:round/>
+                      <a:headEnd type="none" w="med" len="med"/>
+                      <a:tailEnd type="none" w="med" len="med"/>
+                    </a:lnT>
+                    <a:lnB w="9525" cap="flat" cmpd="sng" algn="ctr">
+                      <a:solidFill>
+                        <a:srgbClr val="C9D0D7"/>
+                      </a:solidFill>
+                      <a:prstDash val="solid"/>
+                      <a:round/>
+                      <a:headEnd type="none" w="med" len="med"/>
+                      <a:tailEnd type="none" w="med" len="med"/>
+                    </a:lnB>
+                    <a:solidFill>
+                      <a:srgbClr val="F1F3F5"/>
+                    </a:solidFill>
+                  </a:tcPr>
+                </a:tc>
+                <a:tc>
+                  <a:txBody>
+                    <a:bodyPr/>
+                    <a:lstStyle/>
+                    <a:p>
+                      <a:pPr indent="0" marL="0">
+                        <a:buNone/>
+                      </a:pPr>
+                      <a:r>
+                        <a:rPr lang="en-US" sz="1200" b="1" dirty="0">
+                          <a:solidFill>
+                            <a:srgbClr val="1F2933"/>
+                          </a:solidFill>
+                          <a:latin typeface="Calibri" pitchFamily="34" charset="0"/>
+                          <a:ea typeface="Calibri" pitchFamily="34" charset="-122"/>
+                          <a:cs typeface="Calibri" pitchFamily="34" charset="-120"/>
+                        </a:rPr>
+                        <a:t>Test</a:t>
+                      </a:r>
+                      <a:endParaRPr lang="en-US" sz="1200" dirty="0">
+                        <a:latin typeface="Calibri" charset="0"/>
+                        <a:ea typeface="Calibri" charset="0"/>
+                        <a:cs typeface="Calibri" charset="0"/>
+                      </a:endParaRPr>
+                    </a:p>
+                  </a:txBody>
+                  <a:tcPr marL="76200" marR="76200" marT="38100" marB="38100" anchor="ctr">
+                    <a:lnL w="9525" cap="flat" cmpd="sng" algn="ctr">
+                      <a:solidFill>
+                        <a:srgbClr val="C9D0D7"/>
+                      </a:solidFill>
+                      <a:prstDash val="solid"/>
+                      <a:round/>
+                      <a:headEnd type="none" w="med" len="med"/>
+                      <a:tailEnd type="none" w="med" len="med"/>
+                    </a:lnL>
+                    <a:lnR w="9525" cap="flat" cmpd="sng" algn="ctr">
+                      <a:solidFill>
+                        <a:srgbClr val="C9D0D7"/>
+                      </a:solidFill>
+                      <a:prstDash val="solid"/>
+                      <a:round/>
+                      <a:headEnd type="none" w="med" len="med"/>
+                      <a:tailEnd type="none" w="med" len="med"/>
+                    </a:lnR>
+                    <a:lnT w="9525" cap="flat" cmpd="sng" algn="ctr">
+                      <a:solidFill>
+                        <a:srgbClr val="C9D0D7"/>
+                      </a:solidFill>
+                      <a:prstDash val="solid"/>
+                      <a:round/>
+                      <a:headEnd type="none" w="med" len="med"/>
+                      <a:tailEnd type="none" w="med" len="med"/>
+                    </a:lnT>
+                    <a:lnB w="9525" cap="flat" cmpd="sng" algn="ctr">
+                      <a:solidFill>
+                        <a:srgbClr val="C9D0D7"/>
+                      </a:solidFill>
+                      <a:prstDash val="solid"/>
+                      <a:round/>
+                      <a:headEnd type="none" w="med" len="med"/>
+                      <a:tailEnd type="none" w="med" len="med"/>
+                    </a:lnB>
+                    <a:solidFill>
+                      <a:srgbClr val="F1F3F5"/>
+                    </a:solidFill>
+                  </a:tcPr>
+                </a:tc>
+                <a:tc>
+                  <a:txBody>
+                    <a:bodyPr/>
+                    <a:lstStyle/>
+                    <a:p>
+                      <a:pPr indent="0" marL="0">
+                        <a:buNone/>
+                      </a:pPr>
+                      <a:r>
+                        <a:rPr lang="en-US" sz="1200" b="1" dirty="0">
+                          <a:solidFill>
+                            <a:srgbClr val="1F2933"/>
+                          </a:solidFill>
+                          <a:latin typeface="Calibri" pitchFamily="34" charset="0"/>
+                          <a:ea typeface="Calibri" pitchFamily="34" charset="-122"/>
+                          <a:cs typeface="Calibri" pitchFamily="34" charset="-120"/>
+                        </a:rPr>
+                        <a:t>Result</a:t>
+                      </a:r>
+                      <a:endParaRPr lang="en-US" sz="1200" dirty="0">
+                        <a:latin typeface="Calibri" charset="0"/>
+                        <a:ea typeface="Calibri" charset="0"/>
+                        <a:cs typeface="Calibri" charset="0"/>
+                      </a:endParaRPr>
+                    </a:p>
+                  </a:txBody>
+                  <a:tcPr marL="76200" marR="76200" marT="38100" marB="38100" anchor="ctr">
+                    <a:lnL w="9525" cap="flat" cmpd="sng" algn="ctr">
+                      <a:solidFill>
+                        <a:srgbClr val="C9D0D7"/>
+                      </a:solidFill>
+                      <a:prstDash val="solid"/>
+                      <a:round/>
+                      <a:headEnd type="none" w="med" len="med"/>
+                      <a:tailEnd type="none" w="med" len="med"/>
+                    </a:lnL>
+                    <a:lnR w="9525" cap="flat" cmpd="sng" algn="ctr">
+                      <a:solidFill>
+                        <a:srgbClr val="C9D0D7"/>
+                      </a:solidFill>
+                      <a:prstDash val="solid"/>
+                      <a:round/>
+                      <a:headEnd type="none" w="med" len="med"/>
+                      <a:tailEnd type="none" w="med" len="med"/>
+                    </a:lnR>
+                    <a:lnT w="9525" cap="flat" cmpd="sng" algn="ctr">
+                      <a:solidFill>
+                        <a:srgbClr val="C9D0D7"/>
+                      </a:solidFill>
+                      <a:prstDash val="solid"/>
+                      <a:round/>
+                      <a:headEnd type="none" w="med" len="med"/>
+                      <a:tailEnd type="none" w="med" len="med"/>
+                    </a:lnT>
+                    <a:lnB w="9525" cap="flat" cmpd="sng" algn="ctr">
+                      <a:solidFill>
+                        <a:srgbClr val="C9D0D7"/>
+                      </a:solidFill>
+                      <a:prstDash val="solid"/>
+                      <a:round/>
+                      <a:headEnd type="none" w="med" len="med"/>
+                      <a:tailEnd type="none" w="med" len="med"/>
+                    </a:lnB>
+                    <a:solidFill>
+                      <a:srgbClr val="F1F3F5"/>
+                    </a:solidFill>
+                  </a:tcPr>
+                </a:tc>
+              </a:tr>
+              <a:tr h="320040">
+                <a:tc>
+                  <a:txBody>
+                    <a:bodyPr/>
+                    <a:lstStyle/>
+                    <a:p>
+                      <a:pPr indent="0" marL="0">
+                        <a:buNone/>
+                      </a:pPr>
+                      <a:r>
+                        <a:rPr lang="en-US" sz="1200" dirty="0">
+                          <a:solidFill>
+                            <a:srgbClr val="1F2933"/>
+                          </a:solidFill>
+                          <a:latin typeface="Calibri" pitchFamily="34" charset="0"/>
+                          <a:ea typeface="Calibri" pitchFamily="34" charset="-122"/>
+                          <a:cs typeface="Calibri" pitchFamily="34" charset="-120"/>
+                        </a:rPr>
+                        <a:t>Python sim</a:t>
+                      </a:r>
+                      <a:endParaRPr lang="en-US" sz="1200" dirty="0">
+                        <a:latin typeface="Calibri" charset="0"/>
+                        <a:ea typeface="Calibri" charset="0"/>
+                        <a:cs typeface="Calibri" charset="0"/>
+                      </a:endParaRPr>
+                    </a:p>
+                  </a:txBody>
+                  <a:tcPr marL="76200" marR="76200" marT="38100" marB="38100" anchor="ctr">
+                    <a:lnL w="9525" cap="flat" cmpd="sng" algn="ctr">
+                      <a:solidFill>
+                        <a:srgbClr val="C9D0D7"/>
+                      </a:solidFill>
+                      <a:prstDash val="solid"/>
+                      <a:round/>
+                      <a:headEnd type="none" w="med" len="med"/>
+                      <a:tailEnd type="none" w="med" len="med"/>
+                    </a:lnL>
+                    <a:lnR w="9525" cap="flat" cmpd="sng" algn="ctr">
+                      <a:solidFill>
+                        <a:srgbClr val="C9D0D7"/>
+                      </a:solidFill>
+                      <a:prstDash val="solid"/>
+                      <a:round/>
+                      <a:headEnd type="none" w="med" len="med"/>
+                      <a:tailEnd type="none" w="med" len="med"/>
+                    </a:lnR>
+                    <a:lnT w="9525" cap="flat" cmpd="sng" algn="ctr">
+                      <a:solidFill>
+                        <a:srgbClr val="C9D0D7"/>
+                      </a:solidFill>
+                      <a:prstDash val="solid"/>
+                      <a:round/>
+                      <a:headEnd type="none" w="med" len="med"/>
+                      <a:tailEnd type="none" w="med" len="med"/>
+                    </a:lnT>
+                    <a:lnB w="9525" cap="flat" cmpd="sng" algn="ctr">
+                      <a:solidFill>
+                        <a:srgbClr val="C9D0D7"/>
+                      </a:solidFill>
+                      <a:prstDash val="solid"/>
+                      <a:round/>
+                      <a:headEnd type="none" w="med" len="med"/>
+                      <a:tailEnd type="none" w="med" len="med"/>
+                    </a:lnB>
+                  </a:tcPr>
+                </a:tc>
+                <a:tc>
+                  <a:txBody>
+                    <a:bodyPr/>
+                    <a:lstStyle/>
+                    <a:p>
+                      <a:pPr indent="0" marL="0">
+                        <a:buNone/>
+                      </a:pPr>
+                      <a:r>
+                        <a:rPr lang="en-US" sz="1200" dirty="0">
+                          <a:solidFill>
+                            <a:srgbClr val="1F2933"/>
+                          </a:solidFill>
+                          <a:latin typeface="Calibri" pitchFamily="34" charset="0"/>
+                          <a:ea typeface="Calibri" pitchFamily="34" charset="-122"/>
+                          <a:cs typeface="Calibri" pitchFamily="34" charset="-120"/>
+                        </a:rPr>
+                        <a:t>27 g quadrotor, M1 at 50% RPM on B → C</a:t>
+                      </a:r>
+                      <a:endParaRPr lang="en-US" sz="1200" dirty="0">
+                        <a:latin typeface="Calibri" charset="0"/>
+                        <a:ea typeface="Calibri" charset="0"/>
+                        <a:cs typeface="Calibri" charset="0"/>
+                      </a:endParaRPr>
+                    </a:p>
+                  </a:txBody>
+                  <a:tcPr marL="76200" marR="76200" marT="38100" marB="38100" anchor="ctr">
+                    <a:lnL w="9525" cap="flat" cmpd="sng" algn="ctr">
+                      <a:solidFill>
+                        <a:srgbClr val="C9D0D7"/>
+                      </a:solidFill>
+                      <a:prstDash val="solid"/>
+                      <a:round/>
+                      <a:headEnd type="none" w="med" len="med"/>
+                      <a:tailEnd type="none" w="med" len="med"/>
+                    </a:lnL>
+                    <a:lnR w="9525" cap="flat" cmpd="sng" algn="ctr">
+                      <a:solidFill>
+                        <a:srgbClr val="C9D0D7"/>
+                      </a:solidFill>
+                      <a:prstDash val="solid"/>
+                      <a:round/>
+                      <a:headEnd type="none" w="med" len="med"/>
+                      <a:tailEnd type="none" w="med" len="med"/>
+                    </a:lnR>
+                    <a:lnT w="9525" cap="flat" cmpd="sng" algn="ctr">
+                      <a:solidFill>
+                        <a:srgbClr val="C9D0D7"/>
+                      </a:solidFill>
+                      <a:prstDash val="solid"/>
+                      <a:round/>
+                      <a:headEnd type="none" w="med" len="med"/>
+                      <a:tailEnd type="none" w="med" len="med"/>
+                    </a:lnT>
+                    <a:lnB w="9525" cap="flat" cmpd="sng" algn="ctr">
+                      <a:solidFill>
+                        <a:srgbClr val="C9D0D7"/>
+                      </a:solidFill>
+                      <a:prstDash val="solid"/>
+                      <a:round/>
+                      <a:headEnd type="none" w="med" len="med"/>
+                      <a:tailEnd type="none" w="med" len="med"/>
+                    </a:lnB>
+                  </a:tcPr>
+                </a:tc>
+                <a:tc>
+                  <a:txBody>
+                    <a:bodyPr/>
+                    <a:lstStyle/>
+                    <a:p>
+                      <a:pPr indent="0" marL="0">
+                        <a:buNone/>
+                      </a:pPr>
+                      <a:r>
+                        <a:rPr lang="en-US" sz="1200" dirty="0">
+                          <a:solidFill>
+                            <a:srgbClr val="1F2933"/>
+                          </a:solidFill>
+                          <a:latin typeface="Calibri" pitchFamily="34" charset="0"/>
+                          <a:ea typeface="Calibri" pitchFamily="34" charset="-122"/>
+                          <a:cs typeface="Calibri" pitchFamily="34" charset="-120"/>
+                        </a:rPr>
+                        <a:t>Stock flips; ours finishes the rectangle</a:t>
+                      </a:r>
+                      <a:endParaRPr lang="en-US" sz="1200" dirty="0">
+                        <a:latin typeface="Calibri" charset="0"/>
+                        <a:ea typeface="Calibri" charset="0"/>
+                        <a:cs typeface="Calibri" charset="0"/>
+                      </a:endParaRPr>
+                    </a:p>
+                  </a:txBody>
+                  <a:tcPr marL="76200" marR="76200" marT="38100" marB="38100" anchor="ctr">
+                    <a:lnL w="9525" cap="flat" cmpd="sng" algn="ctr">
+                      <a:solidFill>
+                        <a:srgbClr val="C9D0D7"/>
+                      </a:solidFill>
+                      <a:prstDash val="solid"/>
+                      <a:round/>
+                      <a:headEnd type="none" w="med" len="med"/>
+                      <a:tailEnd type="none" w="med" len="med"/>
+                    </a:lnL>
+                    <a:lnR w="9525" cap="flat" cmpd="sng" algn="ctr">
+                      <a:solidFill>
+                        <a:srgbClr val="C9D0D7"/>
+                      </a:solidFill>
+                      <a:prstDash val="solid"/>
+                      <a:round/>
+                      <a:headEnd type="none" w="med" len="med"/>
+                      <a:tailEnd type="none" w="med" len="med"/>
+                    </a:lnR>
+                    <a:lnT w="9525" cap="flat" cmpd="sng" algn="ctr">
+                      <a:solidFill>
+                        <a:srgbClr val="C9D0D7"/>
+                      </a:solidFill>
+                      <a:prstDash val="solid"/>
+                      <a:round/>
+                      <a:headEnd type="none" w="med" len="med"/>
+                      <a:tailEnd type="none" w="med" len="med"/>
+                    </a:lnT>
+                    <a:lnB w="9525" cap="flat" cmpd="sng" algn="ctr">
+                      <a:solidFill>
+                        <a:srgbClr val="C9D0D7"/>
+                      </a:solidFill>
+                      <a:prstDash val="solid"/>
+                      <a:round/>
+                      <a:headEnd type="none" w="med" len="med"/>
+                      <a:tailEnd type="none" w="med" len="med"/>
+                    </a:lnB>
+                  </a:tcPr>
+                </a:tc>
+              </a:tr>
+              <a:tr h="320040">
+                <a:tc>
+                  <a:txBody>
+                    <a:bodyPr/>
+                    <a:lstStyle/>
+                    <a:p>
+                      <a:pPr indent="0" marL="0">
+                        <a:buNone/>
+                      </a:pPr>
+                      <a:r>
+                        <a:rPr lang="en-US" sz="1200" dirty="0">
+                          <a:solidFill>
+                            <a:srgbClr val="1F2933"/>
+                          </a:solidFill>
+                          <a:latin typeface="Calibri" pitchFamily="34" charset="0"/>
+                          <a:ea typeface="Calibri" pitchFamily="34" charset="-122"/>
+                          <a:cs typeface="Calibri" pitchFamily="34" charset="-120"/>
+                        </a:rPr>
+                        <a:t>Python sim</a:t>
+                      </a:r>
+                      <a:endParaRPr lang="en-US" sz="1200" dirty="0">
+                        <a:latin typeface="Calibri" charset="0"/>
+                        <a:ea typeface="Calibri" charset="0"/>
+                        <a:cs typeface="Calibri" charset="0"/>
+                      </a:endParaRPr>
+                    </a:p>
+                  </a:txBody>
+                  <a:tcPr marL="76200" marR="76200" marT="38100" marB="38100" anchor="ctr">
+                    <a:lnL w="9525" cap="flat" cmpd="sng" algn="ctr">
+                      <a:solidFill>
+                        <a:srgbClr val="C9D0D7"/>
+                      </a:solidFill>
+                      <a:prstDash val="solid"/>
+                      <a:round/>
+                      <a:headEnd type="none" w="med" len="med"/>
+                      <a:tailEnd type="none" w="med" len="med"/>
+                    </a:lnL>
+                    <a:lnR w="9525" cap="flat" cmpd="sng" algn="ctr">
+                      <a:solidFill>
+                        <a:srgbClr val="C9D0D7"/>
+                      </a:solidFill>
+                      <a:prstDash val="solid"/>
+                      <a:round/>
+                      <a:headEnd type="none" w="med" len="med"/>
+                      <a:tailEnd type="none" w="med" len="med"/>
+                    </a:lnR>
+                    <a:lnT w="9525" cap="flat" cmpd="sng" algn="ctr">
+                      <a:solidFill>
+                        <a:srgbClr val="C9D0D7"/>
+                      </a:solidFill>
+                      <a:prstDash val="solid"/>
+                      <a:round/>
+                      <a:headEnd type="none" w="med" len="med"/>
+                      <a:tailEnd type="none" w="med" len="med"/>
+                    </a:lnT>
+                    <a:lnB w="9525" cap="flat" cmpd="sng" algn="ctr">
+                      <a:solidFill>
+                        <a:srgbClr val="C9D0D7"/>
+                      </a:solidFill>
+                      <a:prstDash val="solid"/>
+                      <a:round/>
+                      <a:headEnd type="none" w="med" len="med"/>
+                      <a:tailEnd type="none" w="med" len="med"/>
+                    </a:lnB>
+                  </a:tcPr>
+                </a:tc>
+                <a:tc>
+                  <a:txBody>
+                    <a:bodyPr/>
+                    <a:lstStyle/>
+                    <a:p>
+                      <a:pPr indent="0" marL="0">
+                        <a:buNone/>
+                      </a:pPr>
+                      <a:r>
+                        <a:rPr lang="en-US" sz="1200" dirty="0">
+                          <a:solidFill>
+                            <a:srgbClr val="1F2933"/>
+                          </a:solidFill>
+                          <a:latin typeface="Calibri" pitchFamily="34" charset="0"/>
+                          <a:ea typeface="Calibri" pitchFamily="34" charset="-122"/>
+                          <a:cs typeface="Calibri" pitchFamily="34" charset="-120"/>
+                        </a:rPr>
+                        <a:t>Same, with 2 m/s wind</a:t>
+                      </a:r>
+                      <a:endParaRPr lang="en-US" sz="1200" dirty="0">
+                        <a:latin typeface="Calibri" charset="0"/>
+                        <a:ea typeface="Calibri" charset="0"/>
+                        <a:cs typeface="Calibri" charset="0"/>
+                      </a:endParaRPr>
+                    </a:p>
+                  </a:txBody>
+                  <a:tcPr marL="76200" marR="76200" marT="38100" marB="38100" anchor="ctr">
+                    <a:lnL w="9525" cap="flat" cmpd="sng" algn="ctr">
+                      <a:solidFill>
+                        <a:srgbClr val="C9D0D7"/>
+                      </a:solidFill>
+                      <a:prstDash val="solid"/>
+                      <a:round/>
+                      <a:headEnd type="none" w="med" len="med"/>
+                      <a:tailEnd type="none" w="med" len="med"/>
+                    </a:lnL>
+                    <a:lnR w="9525" cap="flat" cmpd="sng" algn="ctr">
+                      <a:solidFill>
+                        <a:srgbClr val="C9D0D7"/>
+                      </a:solidFill>
+                      <a:prstDash val="solid"/>
+                      <a:round/>
+                      <a:headEnd type="none" w="med" len="med"/>
+                      <a:tailEnd type="none" w="med" len="med"/>
+                    </a:lnR>
+                    <a:lnT w="9525" cap="flat" cmpd="sng" algn="ctr">
+                      <a:solidFill>
+                        <a:srgbClr val="C9D0D7"/>
+                      </a:solidFill>
+                      <a:prstDash val="solid"/>
+                      <a:round/>
+                      <a:headEnd type="none" w="med" len="med"/>
+                      <a:tailEnd type="none" w="med" len="med"/>
+                    </a:lnT>
+                    <a:lnB w="9525" cap="flat" cmpd="sng" algn="ctr">
+                      <a:solidFill>
+                        <a:srgbClr val="C9D0D7"/>
+                      </a:solidFill>
+                      <a:prstDash val="solid"/>
+                      <a:round/>
+                      <a:headEnd type="none" w="med" len="med"/>
+                      <a:tailEnd type="none" w="med" len="med"/>
+                    </a:lnB>
+                  </a:tcPr>
+                </a:tc>
+                <a:tc>
+                  <a:txBody>
+                    <a:bodyPr/>
+                    <a:lstStyle/>
+                    <a:p>
+                      <a:pPr indent="0" marL="0">
+                        <a:buNone/>
+                      </a:pPr>
+                      <a:r>
+                        <a:rPr lang="en-US" sz="1200" dirty="0">
+                          <a:solidFill>
+                            <a:srgbClr val="1F2933"/>
+                          </a:solidFill>
+                          <a:latin typeface="Calibri" pitchFamily="34" charset="0"/>
+                          <a:ea typeface="Calibri" pitchFamily="34" charset="-122"/>
+                          <a:cs typeface="Calibri" pitchFamily="34" charset="-120"/>
+                        </a:rPr>
+                        <a:t>Ours finishes; Kalman filter finds the wind force (20 mN)</a:t>
+                      </a:r>
+                      <a:endParaRPr lang="en-US" sz="1200" dirty="0">
+                        <a:latin typeface="Calibri" charset="0"/>
+                        <a:ea typeface="Calibri" charset="0"/>
+                        <a:cs typeface="Calibri" charset="0"/>
+                      </a:endParaRPr>
+                    </a:p>
+                  </a:txBody>
+                  <a:tcPr marL="76200" marR="76200" marT="38100" marB="38100" anchor="ctr">
+                    <a:lnL w="9525" cap="flat" cmpd="sng" algn="ctr">
+                      <a:solidFill>
+                        <a:srgbClr val="C9D0D7"/>
+                      </a:solidFill>
+                      <a:prstDash val="solid"/>
+                      <a:round/>
+                      <a:headEnd type="none" w="med" len="med"/>
+                      <a:tailEnd type="none" w="med" len="med"/>
+                    </a:lnL>
+                    <a:lnR w="9525" cap="flat" cmpd="sng" algn="ctr">
+                      <a:solidFill>
+                        <a:srgbClr val="C9D0D7"/>
+                      </a:solidFill>
+                      <a:prstDash val="solid"/>
+                      <a:round/>
+                      <a:headEnd type="none" w="med" len="med"/>
+                      <a:tailEnd type="none" w="med" len="med"/>
+                    </a:lnR>
+                    <a:lnT w="9525" cap="flat" cmpd="sng" algn="ctr">
+                      <a:solidFill>
+                        <a:srgbClr val="C9D0D7"/>
+                      </a:solidFill>
+                      <a:prstDash val="solid"/>
+                      <a:round/>
+                      <a:headEnd type="none" w="med" len="med"/>
+                      <a:tailEnd type="none" w="med" len="med"/>
+                    </a:lnT>
+                    <a:lnB w="9525" cap="flat" cmpd="sng" algn="ctr">
+                      <a:solidFill>
+                        <a:srgbClr val="C9D0D7"/>
+                      </a:solidFill>
+                      <a:prstDash val="solid"/>
+                      <a:round/>
+                      <a:headEnd type="none" w="med" len="med"/>
+                      <a:tailEnd type="none" w="med" len="med"/>
+                    </a:lnB>
+                  </a:tcPr>
+                </a:tc>
+              </a:tr>
+              <a:tr h="320040">
+                <a:tc>
+                  <a:txBody>
+                    <a:bodyPr/>
+                    <a:lstStyle/>
+                    <a:p>
+                      <a:pPr indent="0" marL="0">
+                        <a:buNone/>
+                      </a:pPr>
+                      <a:r>
+                        <a:rPr lang="en-US" sz="1200" dirty="0">
+                          <a:solidFill>
+                            <a:srgbClr val="1F2933"/>
+                          </a:solidFill>
+                          <a:latin typeface="Calibri" pitchFamily="34" charset="0"/>
+                          <a:ea typeface="Calibri" pitchFamily="34" charset="-122"/>
+                          <a:cs typeface="Calibri" pitchFamily="34" charset="-120"/>
+                        </a:rPr>
+                        <a:t>CrazySim</a:t>
+                      </a:r>
+                      <a:endParaRPr lang="en-US" sz="1200" dirty="0">
+                        <a:latin typeface="Calibri" charset="0"/>
+                        <a:ea typeface="Calibri" charset="0"/>
+                        <a:cs typeface="Calibri" charset="0"/>
+                      </a:endParaRPr>
+                    </a:p>
+                  </a:txBody>
+                  <a:tcPr marL="76200" marR="76200" marT="38100" marB="38100" anchor="ctr">
+                    <a:lnL w="9525" cap="flat" cmpd="sng" algn="ctr">
+                      <a:solidFill>
+                        <a:srgbClr val="C9D0D7"/>
+                      </a:solidFill>
+                      <a:prstDash val="solid"/>
+                      <a:round/>
+                      <a:headEnd type="none" w="med" len="med"/>
+                      <a:tailEnd type="none" w="med" len="med"/>
+                    </a:lnL>
+                    <a:lnR w="9525" cap="flat" cmpd="sng" algn="ctr">
+                      <a:solidFill>
+                        <a:srgbClr val="C9D0D7"/>
+                      </a:solidFill>
+                      <a:prstDash val="solid"/>
+                      <a:round/>
+                      <a:headEnd type="none" w="med" len="med"/>
+                      <a:tailEnd type="none" w="med" len="med"/>
+                    </a:lnR>
+                    <a:lnT w="9525" cap="flat" cmpd="sng" algn="ctr">
+                      <a:solidFill>
+                        <a:srgbClr val="C9D0D7"/>
+                      </a:solidFill>
+                      <a:prstDash val="solid"/>
+                      <a:round/>
+                      <a:headEnd type="none" w="med" len="med"/>
+                      <a:tailEnd type="none" w="med" len="med"/>
+                    </a:lnT>
+                    <a:lnB w="9525" cap="flat" cmpd="sng" algn="ctr">
+                      <a:solidFill>
+                        <a:srgbClr val="C9D0D7"/>
+                      </a:solidFill>
+                      <a:prstDash val="solid"/>
+                      <a:round/>
+                      <a:headEnd type="none" w="med" len="med"/>
+                      <a:tailEnd type="none" w="med" len="med"/>
+                    </a:lnB>
+                  </a:tcPr>
+                </a:tc>
+                <a:tc>
+                  <a:txBody>
+                    <a:bodyPr/>
+                    <a:lstStyle/>
+                    <a:p>
+                      <a:pPr indent="0" marL="0">
+                        <a:buNone/>
+                      </a:pPr>
+                      <a:r>
+                        <a:rPr lang="en-US" sz="1200" dirty="0">
+                          <a:solidFill>
+                            <a:srgbClr val="1F2933"/>
+                          </a:solidFill>
+                          <a:latin typeface="Calibri" pitchFamily="34" charset="0"/>
+                          <a:ea typeface="Calibri" pitchFamily="34" charset="-122"/>
+                          <a:cs typeface="Calibri" pitchFamily="34" charset="-120"/>
+                        </a:rPr>
+                        <a:t>Crazyflie 2.1 Brushless, M1 at 50% RPM</a:t>
+                      </a:r>
+                      <a:endParaRPr lang="en-US" sz="1200" dirty="0">
+                        <a:latin typeface="Calibri" charset="0"/>
+                        <a:ea typeface="Calibri" charset="0"/>
+                        <a:cs typeface="Calibri" charset="0"/>
+                      </a:endParaRPr>
+                    </a:p>
+                  </a:txBody>
+                  <a:tcPr marL="76200" marR="76200" marT="38100" marB="38100" anchor="ctr">
+                    <a:lnL w="9525" cap="flat" cmpd="sng" algn="ctr">
+                      <a:solidFill>
+                        <a:srgbClr val="C9D0D7"/>
+                      </a:solidFill>
+                      <a:prstDash val="solid"/>
+                      <a:round/>
+                      <a:headEnd type="none" w="med" len="med"/>
+                      <a:tailEnd type="none" w="med" len="med"/>
+                    </a:lnL>
+                    <a:lnR w="9525" cap="flat" cmpd="sng" algn="ctr">
+                      <a:solidFill>
+                        <a:srgbClr val="C9D0D7"/>
+                      </a:solidFill>
+                      <a:prstDash val="solid"/>
+                      <a:round/>
+                      <a:headEnd type="none" w="med" len="med"/>
+                      <a:tailEnd type="none" w="med" len="med"/>
+                    </a:lnR>
+                    <a:lnT w="9525" cap="flat" cmpd="sng" algn="ctr">
+                      <a:solidFill>
+                        <a:srgbClr val="C9D0D7"/>
+                      </a:solidFill>
+                      <a:prstDash val="solid"/>
+                      <a:round/>
+                      <a:headEnd type="none" w="med" len="med"/>
+                      <a:tailEnd type="none" w="med" len="med"/>
+                    </a:lnT>
+                    <a:lnB w="9525" cap="flat" cmpd="sng" algn="ctr">
+                      <a:solidFill>
+                        <a:srgbClr val="C9D0D7"/>
+                      </a:solidFill>
+                      <a:prstDash val="solid"/>
+                      <a:round/>
+                      <a:headEnd type="none" w="med" len="med"/>
+                      <a:tailEnd type="none" w="med" len="med"/>
+                    </a:lnB>
+                  </a:tcPr>
+                </a:tc>
+                <a:tc>
+                  <a:txBody>
+                    <a:bodyPr/>
+                    <a:lstStyle/>
+                    <a:p>
+                      <a:pPr indent="0" marL="0">
+                        <a:buNone/>
+                      </a:pPr>
+                      <a:r>
+                        <a:rPr lang="en-US" sz="1200" dirty="0">
+                          <a:solidFill>
+                            <a:srgbClr val="1F2933"/>
+                          </a:solidFill>
+                          <a:latin typeface="Calibri" pitchFamily="34" charset="0"/>
+                          <a:ea typeface="Calibri" pitchFamily="34" charset="-122"/>
+                          <a:cs typeface="Calibri" pitchFamily="34" charset="-120"/>
+                        </a:rPr>
+                        <a:t>Stock crashes; ours finishes the rectangle</a:t>
+                      </a:r>
+                      <a:endParaRPr lang="en-US" sz="1200" dirty="0">
+                        <a:latin typeface="Calibri" charset="0"/>
+                        <a:ea typeface="Calibri" charset="0"/>
+                        <a:cs typeface="Calibri" charset="0"/>
+                      </a:endParaRPr>
+                    </a:p>
+                  </a:txBody>
+                  <a:tcPr marL="76200" marR="76200" marT="38100" marB="38100" anchor="ctr">
+                    <a:lnL w="9525" cap="flat" cmpd="sng" algn="ctr">
+                      <a:solidFill>
+                        <a:srgbClr val="C9D0D7"/>
+                      </a:solidFill>
+                      <a:prstDash val="solid"/>
+                      <a:round/>
+                      <a:headEnd type="none" w="med" len="med"/>
+                      <a:tailEnd type="none" w="med" len="med"/>
+                    </a:lnL>
+                    <a:lnR w="9525" cap="flat" cmpd="sng" algn="ctr">
+                      <a:solidFill>
+                        <a:srgbClr val="C9D0D7"/>
+                      </a:solidFill>
+                      <a:prstDash val="solid"/>
+                      <a:round/>
+                      <a:headEnd type="none" w="med" len="med"/>
+                      <a:tailEnd type="none" w="med" len="med"/>
+                    </a:lnR>
+                    <a:lnT w="9525" cap="flat" cmpd="sng" algn="ctr">
+                      <a:solidFill>
+                        <a:srgbClr val="C9D0D7"/>
+                      </a:solidFill>
+                      <a:prstDash val="solid"/>
+                      <a:round/>
+                      <a:headEnd type="none" w="med" len="med"/>
+                      <a:tailEnd type="none" w="med" len="med"/>
+                    </a:lnT>
+                    <a:lnB w="9525" cap="flat" cmpd="sng" algn="ctr">
+                      <a:solidFill>
+                        <a:srgbClr val="C9D0D7"/>
+                      </a:solidFill>
+                      <a:prstDash val="solid"/>
+                      <a:round/>
+                      <a:headEnd type="none" w="med" len="med"/>
+                      <a:tailEnd type="none" w="med" len="med"/>
+                    </a:lnB>
+                  </a:tcPr>
+                </a:tc>
+              </a:tr>
+              <a:tr h="320040">
+                <a:tc>
+                  <a:txBody>
+                    <a:bodyPr/>
+                    <a:lstStyle/>
+                    <a:p>
+                      <a:pPr indent="0" marL="0">
+                        <a:buNone/>
+                      </a:pPr>
+                      <a:r>
+                        <a:rPr lang="en-US" sz="1200" dirty="0">
+                          <a:solidFill>
+                            <a:srgbClr val="1F2933"/>
+                          </a:solidFill>
+                          <a:latin typeface="Calibri" pitchFamily="34" charset="0"/>
+                          <a:ea typeface="Calibri" pitchFamily="34" charset="-122"/>
+                          <a:cs typeface="Calibri" pitchFamily="34" charset="-120"/>
+                        </a:rPr>
+                        <a:t>CrazySim</a:t>
+                      </a:r>
+                      <a:endParaRPr lang="en-US" sz="1200" dirty="0">
+                        <a:latin typeface="Calibri" charset="0"/>
+                        <a:ea typeface="Calibri" charset="0"/>
+                        <a:cs typeface="Calibri" charset="0"/>
+                      </a:endParaRPr>
+                    </a:p>
+                  </a:txBody>
+                  <a:tcPr marL="76200" marR="76200" marT="38100" marB="38100" anchor="ctr">
+                    <a:lnL w="9525" cap="flat" cmpd="sng" algn="ctr">
+                      <a:solidFill>
+                        <a:srgbClr val="C9D0D7"/>
+                      </a:solidFill>
+                      <a:prstDash val="solid"/>
+                      <a:round/>
+                      <a:headEnd type="none" w="med" len="med"/>
+                      <a:tailEnd type="none" w="med" len="med"/>
+                    </a:lnL>
+                    <a:lnR w="9525" cap="flat" cmpd="sng" algn="ctr">
+                      <a:solidFill>
+                        <a:srgbClr val="C9D0D7"/>
+                      </a:solidFill>
+                      <a:prstDash val="solid"/>
+                      <a:round/>
+                      <a:headEnd type="none" w="med" len="med"/>
+                      <a:tailEnd type="none" w="med" len="med"/>
+                    </a:lnR>
+                    <a:lnT w="9525" cap="flat" cmpd="sng" algn="ctr">
+                      <a:solidFill>
+                        <a:srgbClr val="C9D0D7"/>
+                      </a:solidFill>
+                      <a:prstDash val="solid"/>
+                      <a:round/>
+                      <a:headEnd type="none" w="med" len="med"/>
+                      <a:tailEnd type="none" w="med" len="med"/>
+                    </a:lnT>
+                    <a:lnB w="9525" cap="flat" cmpd="sng" algn="ctr">
+                      <a:solidFill>
+                        <a:srgbClr val="C9D0D7"/>
+                      </a:solidFill>
+                      <a:prstDash val="solid"/>
+                      <a:round/>
+                      <a:headEnd type="none" w="med" len="med"/>
+                      <a:tailEnd type="none" w="med" len="med"/>
+                    </a:lnB>
+                  </a:tcPr>
+                </a:tc>
+                <a:tc>
+                  <a:txBody>
+                    <a:bodyPr/>
+                    <a:lstStyle/>
+                    <a:p>
+                      <a:pPr indent="0" marL="0">
+                        <a:buNone/>
+                      </a:pPr>
+                      <a:r>
+                        <a:rPr lang="en-US" sz="1200" dirty="0">
+                          <a:solidFill>
+                            <a:srgbClr val="1F2933"/>
+                          </a:solidFill>
+                          <a:latin typeface="Calibri" pitchFamily="34" charset="0"/>
+                          <a:ea typeface="Calibri" pitchFamily="34" charset="-122"/>
+                          <a:cs typeface="Calibri" pitchFamily="34" charset="-120"/>
+                        </a:rPr>
+                        <a:t>Crazyflie 2.1 (27 g), M1 at 50% RPM</a:t>
+                      </a:r>
+                      <a:endParaRPr lang="en-US" sz="1200" dirty="0">
+                        <a:latin typeface="Calibri" charset="0"/>
+                        <a:ea typeface="Calibri" charset="0"/>
+                        <a:cs typeface="Calibri" charset="0"/>
+                      </a:endParaRPr>
+                    </a:p>
+                  </a:txBody>
+                  <a:tcPr marL="76200" marR="76200" marT="38100" marB="38100" anchor="ctr">
+                    <a:lnL w="9525" cap="flat" cmpd="sng" algn="ctr">
+                      <a:solidFill>
+                        <a:srgbClr val="C9D0D7"/>
+                      </a:solidFill>
+                      <a:prstDash val="solid"/>
+                      <a:round/>
+                      <a:headEnd type="none" w="med" len="med"/>
+                      <a:tailEnd type="none" w="med" len="med"/>
+                    </a:lnL>
+                    <a:lnR w="9525" cap="flat" cmpd="sng" algn="ctr">
+                      <a:solidFill>
+                        <a:srgbClr val="C9D0D7"/>
+                      </a:solidFill>
+                      <a:prstDash val="solid"/>
+                      <a:round/>
+                      <a:headEnd type="none" w="med" len="med"/>
+                      <a:tailEnd type="none" w="med" len="med"/>
+                    </a:lnR>
+                    <a:lnT w="9525" cap="flat" cmpd="sng" algn="ctr">
+                      <a:solidFill>
+                        <a:srgbClr val="C9D0D7"/>
+                      </a:solidFill>
+                      <a:prstDash val="solid"/>
+                      <a:round/>
+                      <a:headEnd type="none" w="med" len="med"/>
+                      <a:tailEnd type="none" w="med" len="med"/>
+                    </a:lnT>
+                    <a:lnB w="9525" cap="flat" cmpd="sng" algn="ctr">
+                      <a:solidFill>
+                        <a:srgbClr val="C9D0D7"/>
+                      </a:solidFill>
+                      <a:prstDash val="solid"/>
+                      <a:round/>
+                      <a:headEnd type="none" w="med" len="med"/>
+                      <a:tailEnd type="none" w="med" len="med"/>
+                    </a:lnB>
+                  </a:tcPr>
+                </a:tc>
+                <a:tc>
+                  <a:txBody>
+                    <a:bodyPr/>
+                    <a:lstStyle/>
+                    <a:p>
+                      <a:pPr indent="0" marL="0">
+                        <a:buNone/>
+                      </a:pPr>
+                      <a:r>
+                        <a:rPr lang="en-US" sz="1200" dirty="0">
+                          <a:solidFill>
+                            <a:srgbClr val="1F2933"/>
+                          </a:solidFill>
+                          <a:latin typeface="Calibri" pitchFamily="34" charset="0"/>
+                          <a:ea typeface="Calibri" pitchFamily="34" charset="-122"/>
+                          <a:cs typeface="Calibri" pitchFamily="34" charset="-120"/>
+                        </a:rPr>
+                        <a:t>Ours lands level at 0.6 m/s; stock falls at 2.2 m/s</a:t>
+                      </a:r>
+                      <a:endParaRPr lang="en-US" sz="1200" dirty="0">
+                        <a:latin typeface="Calibri" charset="0"/>
+                        <a:ea typeface="Calibri" charset="0"/>
+                        <a:cs typeface="Calibri" charset="0"/>
+                      </a:endParaRPr>
+                    </a:p>
+                  </a:txBody>
+                  <a:tcPr marL="76200" marR="76200" marT="38100" marB="38100" anchor="ctr">
+                    <a:lnL w="9525" cap="flat" cmpd="sng" algn="ctr">
+                      <a:solidFill>
+                        <a:srgbClr val="C9D0D7"/>
+                      </a:solidFill>
+                      <a:prstDash val="solid"/>
+                      <a:round/>
+                      <a:headEnd type="none" w="med" len="med"/>
+                      <a:tailEnd type="none" w="med" len="med"/>
+                    </a:lnL>
+                    <a:lnR w="9525" cap="flat" cmpd="sng" algn="ctr">
+                      <a:solidFill>
+                        <a:srgbClr val="C9D0D7"/>
+                      </a:solidFill>
+                      <a:prstDash val="solid"/>
+                      <a:round/>
+                      <a:headEnd type="none" w="med" len="med"/>
+                      <a:tailEnd type="none" w="med" len="med"/>
+                    </a:lnR>
+                    <a:lnT w="9525" cap="flat" cmpd="sng" algn="ctr">
+                      <a:solidFill>
+                        <a:srgbClr val="C9D0D7"/>
+                      </a:solidFill>
+                      <a:prstDash val="solid"/>
+                      <a:round/>
+                      <a:headEnd type="none" w="med" len="med"/>
+                      <a:tailEnd type="none" w="med" len="med"/>
+                    </a:lnT>
+                    <a:lnB w="9525" cap="flat" cmpd="sng" algn="ctr">
+                      <a:solidFill>
+                        <a:srgbClr val="C9D0D7"/>
+                      </a:solidFill>
+                      <a:prstDash val="solid"/>
+                      <a:round/>
+                      <a:headEnd type="none" w="med" len="med"/>
+                      <a:tailEnd type="none" w="med" len="med"/>
+                    </a:lnB>
+                  </a:tcPr>
+                </a:tc>
+              </a:tr>
+              <a:tr h="320040">
+                <a:tc>
+                  <a:txBody>
+                    <a:bodyPr/>
+                    <a:lstStyle/>
+                    <a:p>
+                      <a:pPr indent="0" marL="0">
+                        <a:buNone/>
+                      </a:pPr>
+                      <a:r>
+                        <a:rPr lang="en-US" sz="1200" dirty="0">
+                          <a:solidFill>
+                            <a:srgbClr val="1F2933"/>
+                          </a:solidFill>
+                          <a:latin typeface="Calibri" pitchFamily="34" charset="0"/>
+                          <a:ea typeface="Calibri" pitchFamily="34" charset="-122"/>
+                          <a:cs typeface="Calibri" pitchFamily="34" charset="-120"/>
+                        </a:rPr>
+                        <a:t>CrazySim</a:t>
+                      </a:r>
+                      <a:endParaRPr lang="en-US" sz="1200" dirty="0">
+                        <a:latin typeface="Calibri" charset="0"/>
+                        <a:ea typeface="Calibri" charset="0"/>
+                        <a:cs typeface="Calibri" charset="0"/>
+                      </a:endParaRPr>
+                    </a:p>
+                  </a:txBody>
+                  <a:tcPr marL="76200" marR="76200" marT="38100" marB="38100" anchor="ctr">
+                    <a:lnL w="9525" cap="flat" cmpd="sng" algn="ctr">
+                      <a:solidFill>
+                        <a:srgbClr val="C9D0D7"/>
+                      </a:solidFill>
+                      <a:prstDash val="solid"/>
+                      <a:round/>
+                      <a:headEnd type="none" w="med" len="med"/>
+                      <a:tailEnd type="none" w="med" len="med"/>
+                    </a:lnL>
+                    <a:lnR w="9525" cap="flat" cmpd="sng" algn="ctr">
+                      <a:solidFill>
+                        <a:srgbClr val="C9D0D7"/>
+                      </a:solidFill>
+                      <a:prstDash val="solid"/>
+                      <a:round/>
+                      <a:headEnd type="none" w="med" len="med"/>
+                      <a:tailEnd type="none" w="med" len="med"/>
+                    </a:lnR>
+                    <a:lnT w="9525" cap="flat" cmpd="sng" algn="ctr">
+                      <a:solidFill>
+                        <a:srgbClr val="C9D0D7"/>
+                      </a:solidFill>
+                      <a:prstDash val="solid"/>
+                      <a:round/>
+                      <a:headEnd type="none" w="med" len="med"/>
+                      <a:tailEnd type="none" w="med" len="med"/>
+                    </a:lnT>
+                    <a:lnB w="9525" cap="flat" cmpd="sng" algn="ctr">
+                      <a:solidFill>
+                        <a:srgbClr val="C9D0D7"/>
+                      </a:solidFill>
+                      <a:prstDash val="solid"/>
+                      <a:round/>
+                      <a:headEnd type="none" w="med" len="med"/>
+                      <a:tailEnd type="none" w="med" len="med"/>
+                    </a:lnB>
+                  </a:tcPr>
+                </a:tc>
+                <a:tc>
+                  <a:txBody>
+                    <a:bodyPr/>
+                    <a:lstStyle/>
+                    <a:p>
+                      <a:pPr indent="0" marL="0">
+                        <a:buNone/>
+                      </a:pPr>
+                      <a:r>
+                        <a:rPr lang="en-US" sz="1200" dirty="0">
+                          <a:solidFill>
+                            <a:srgbClr val="1F2933"/>
+                          </a:solidFill>
+                          <a:latin typeface="Calibri" pitchFamily="34" charset="0"/>
+                          <a:ea typeface="Calibri" pitchFamily="34" charset="-122"/>
+                          <a:cs typeface="Calibri" pitchFamily="34" charset="-120"/>
+                        </a:rPr>
+                        <a:t>Crazyflie 2.1, M1 at half thrust, hover</a:t>
+                      </a:r>
+                      <a:endParaRPr lang="en-US" sz="1200" dirty="0">
+                        <a:latin typeface="Calibri" charset="0"/>
+                        <a:ea typeface="Calibri" charset="0"/>
+                        <a:cs typeface="Calibri" charset="0"/>
+                      </a:endParaRPr>
+                    </a:p>
+                  </a:txBody>
+                  <a:tcPr marL="76200" marR="76200" marT="38100" marB="38100" anchor="ctr">
+                    <a:lnL w="9525" cap="flat" cmpd="sng" algn="ctr">
+                      <a:solidFill>
+                        <a:srgbClr val="C9D0D7"/>
+                      </a:solidFill>
+                      <a:prstDash val="solid"/>
+                      <a:round/>
+                      <a:headEnd type="none" w="med" len="med"/>
+                      <a:tailEnd type="none" w="med" len="med"/>
+                    </a:lnL>
+                    <a:lnR w="9525" cap="flat" cmpd="sng" algn="ctr">
+                      <a:solidFill>
+                        <a:srgbClr val="C9D0D7"/>
+                      </a:solidFill>
+                      <a:prstDash val="solid"/>
+                      <a:round/>
+                      <a:headEnd type="none" w="med" len="med"/>
+                      <a:tailEnd type="none" w="med" len="med"/>
+                    </a:lnR>
+                    <a:lnT w="9525" cap="flat" cmpd="sng" algn="ctr">
+                      <a:solidFill>
+                        <a:srgbClr val="C9D0D7"/>
+                      </a:solidFill>
+                      <a:prstDash val="solid"/>
+                      <a:round/>
+                      <a:headEnd type="none" w="med" len="med"/>
+                      <a:tailEnd type="none" w="med" len="med"/>
+                    </a:lnT>
+                    <a:lnB w="9525" cap="flat" cmpd="sng" algn="ctr">
+                      <a:solidFill>
+                        <a:srgbClr val="C9D0D7"/>
+                      </a:solidFill>
+                      <a:prstDash val="solid"/>
+                      <a:round/>
+                      <a:headEnd type="none" w="med" len="med"/>
+                      <a:tailEnd type="none" w="med" len="med"/>
+                    </a:lnB>
+                  </a:tcPr>
+                </a:tc>
+                <a:tc>
+                  <a:txBody>
+                    <a:bodyPr/>
+                    <a:lstStyle/>
+                    <a:p>
+                      <a:pPr indent="0" marL="0">
+                        <a:buNone/>
+                      </a:pPr>
+                      <a:r>
+                        <a:rPr lang="en-US" sz="1200" dirty="0">
+                          <a:solidFill>
+                            <a:srgbClr val="1F2933"/>
+                          </a:solidFill>
+                          <a:latin typeface="Calibri" pitchFamily="34" charset="0"/>
+                          <a:ea typeface="Calibri" pitchFamily="34" charset="-122"/>
+                          <a:cs typeface="Calibri" pitchFamily="34" charset="-120"/>
+                        </a:rPr>
+                        <a:t>Ours stays level (2 deg); stock crashes</a:t>
+                      </a:r>
+                      <a:endParaRPr lang="en-US" sz="1200" dirty="0">
+                        <a:latin typeface="Calibri" charset="0"/>
+                        <a:ea typeface="Calibri" charset="0"/>
+                        <a:cs typeface="Calibri" charset="0"/>
+                      </a:endParaRPr>
+                    </a:p>
+                  </a:txBody>
+                  <a:tcPr marL="76200" marR="76200" marT="38100" marB="38100" anchor="ctr">
+                    <a:lnL w="9525" cap="flat" cmpd="sng" algn="ctr">
+                      <a:solidFill>
+                        <a:srgbClr val="C9D0D7"/>
+                      </a:solidFill>
+                      <a:prstDash val="solid"/>
+                      <a:round/>
+                      <a:headEnd type="none" w="med" len="med"/>
+                      <a:tailEnd type="none" w="med" len="med"/>
+                    </a:lnL>
+                    <a:lnR w="9525" cap="flat" cmpd="sng" algn="ctr">
+                      <a:solidFill>
+                        <a:srgbClr val="C9D0D7"/>
+                      </a:solidFill>
+                      <a:prstDash val="solid"/>
+                      <a:round/>
+                      <a:headEnd type="none" w="med" len="med"/>
+                      <a:tailEnd type="none" w="med" len="med"/>
+                    </a:lnR>
+                    <a:lnT w="9525" cap="flat" cmpd="sng" algn="ctr">
+                      <a:solidFill>
+                        <a:srgbClr val="C9D0D7"/>
+                      </a:solidFill>
+                      <a:prstDash val="solid"/>
+                      <a:round/>
+                      <a:headEnd type="none" w="med" len="med"/>
+                      <a:tailEnd type="none" w="med" len="med"/>
+                    </a:lnT>
+                    <a:lnB w="9525" cap="flat" cmpd="sng" algn="ctr">
+                      <a:solidFill>
+                        <a:srgbClr val="C9D0D7"/>
+                      </a:solidFill>
+                      <a:prstDash val="solid"/>
+                      <a:round/>
+                      <a:headEnd type="none" w="med" len="med"/>
+                      <a:tailEnd type="none" w="med" len="med"/>
+                    </a:lnB>
+                  </a:tcPr>
+                </a:tc>
+              </a:tr>
+              <a:tr h="320040">
+                <a:tc>
+                  <a:txBody>
+                    <a:bodyPr/>
+                    <a:lstStyle/>
+                    <a:p>
+                      <a:pPr indent="0" marL="0">
+                        <a:buNone/>
+                      </a:pPr>
+                      <a:r>
+                        <a:rPr lang="en-US" sz="1200" dirty="0">
+                          <a:solidFill>
+                            <a:srgbClr val="1F2933"/>
+                          </a:solidFill>
+                          <a:latin typeface="Calibri" pitchFamily="34" charset="0"/>
+                          <a:ea typeface="Calibri" pitchFamily="34" charset="-122"/>
+                          <a:cs typeface="Calibri" pitchFamily="34" charset="-120"/>
+                        </a:rPr>
+                        <a:t>CrazySim</a:t>
+                      </a:r>
+                      <a:endParaRPr lang="en-US" sz="1200" dirty="0">
+                        <a:latin typeface="Calibri" charset="0"/>
+                        <a:ea typeface="Calibri" charset="0"/>
+                        <a:cs typeface="Calibri" charset="0"/>
+                      </a:endParaRPr>
+                    </a:p>
+                  </a:txBody>
+                  <a:tcPr marL="76200" marR="76200" marT="38100" marB="38100" anchor="ctr">
+                    <a:lnL w="9525" cap="flat" cmpd="sng" algn="ctr">
+                      <a:solidFill>
+                        <a:srgbClr val="C9D0D7"/>
+                      </a:solidFill>
+                      <a:prstDash val="solid"/>
+                      <a:round/>
+                      <a:headEnd type="none" w="med" len="med"/>
+                      <a:tailEnd type="none" w="med" len="med"/>
+                    </a:lnL>
+                    <a:lnR w="9525" cap="flat" cmpd="sng" algn="ctr">
+                      <a:solidFill>
+                        <a:srgbClr val="C9D0D7"/>
+                      </a:solidFill>
+                      <a:prstDash val="solid"/>
+                      <a:round/>
+                      <a:headEnd type="none" w="med" len="med"/>
+                      <a:tailEnd type="none" w="med" len="med"/>
+                    </a:lnR>
+                    <a:lnT w="9525" cap="flat" cmpd="sng" algn="ctr">
+                      <a:solidFill>
+                        <a:srgbClr val="C9D0D7"/>
+                      </a:solidFill>
+                      <a:prstDash val="solid"/>
+                      <a:round/>
+                      <a:headEnd type="none" w="med" len="med"/>
+                      <a:tailEnd type="none" w="med" len="med"/>
+                    </a:lnT>
+                    <a:lnB w="9525" cap="flat" cmpd="sng" algn="ctr">
+                      <a:solidFill>
+                        <a:srgbClr val="C9D0D7"/>
+                      </a:solidFill>
+                      <a:prstDash val="solid"/>
+                      <a:round/>
+                      <a:headEnd type="none" w="med" len="med"/>
+                      <a:tailEnd type="none" w="med" len="med"/>
+                    </a:lnB>
+                  </a:tcPr>
+                </a:tc>
+                <a:tc>
+                  <a:txBody>
+                    <a:bodyPr/>
+                    <a:lstStyle/>
+                    <a:p>
+                      <a:pPr indent="0" marL="0">
+                        <a:buNone/>
+                      </a:pPr>
+                      <a:r>
+                        <a:rPr lang="en-US" sz="1200" dirty="0">
+                          <a:solidFill>
+                            <a:srgbClr val="1F2933"/>
+                          </a:solidFill>
+                          <a:latin typeface="Calibri" pitchFamily="34" charset="0"/>
+                          <a:ea typeface="Calibri" pitchFamily="34" charset="-122"/>
+                          <a:cs typeface="Calibri" pitchFamily="34" charset="-120"/>
+                        </a:rPr>
+                        <a:t>Crazyflie 2.1, M1 switched off</a:t>
+                      </a:r>
+                      <a:endParaRPr lang="en-US" sz="1200" dirty="0">
+                        <a:latin typeface="Calibri" charset="0"/>
+                        <a:ea typeface="Calibri" charset="0"/>
+                        <a:cs typeface="Calibri" charset="0"/>
+                      </a:endParaRPr>
+                    </a:p>
+                  </a:txBody>
+                  <a:tcPr marL="76200" marR="76200" marT="38100" marB="38100" anchor="ctr">
+                    <a:lnL w="9525" cap="flat" cmpd="sng" algn="ctr">
+                      <a:solidFill>
+                        <a:srgbClr val="C9D0D7"/>
+                      </a:solidFill>
+                      <a:prstDash val="solid"/>
+                      <a:round/>
+                      <a:headEnd type="none" w="med" len="med"/>
+                      <a:tailEnd type="none" w="med" len="med"/>
+                    </a:lnL>
+                    <a:lnR w="9525" cap="flat" cmpd="sng" algn="ctr">
+                      <a:solidFill>
+                        <a:srgbClr val="C9D0D7"/>
+                      </a:solidFill>
+                      <a:prstDash val="solid"/>
+                      <a:round/>
+                      <a:headEnd type="none" w="med" len="med"/>
+                      <a:tailEnd type="none" w="med" len="med"/>
+                    </a:lnR>
+                    <a:lnT w="9525" cap="flat" cmpd="sng" algn="ctr">
+                      <a:solidFill>
+                        <a:srgbClr val="C9D0D7"/>
+                      </a:solidFill>
+                      <a:prstDash val="solid"/>
+                      <a:round/>
+                      <a:headEnd type="none" w="med" len="med"/>
+                      <a:tailEnd type="none" w="med" len="med"/>
+                    </a:lnT>
+                    <a:lnB w="9525" cap="flat" cmpd="sng" algn="ctr">
+                      <a:solidFill>
+                        <a:srgbClr val="C9D0D7"/>
+                      </a:solidFill>
+                      <a:prstDash val="solid"/>
+                      <a:round/>
+                      <a:headEnd type="none" w="med" len="med"/>
+                      <a:tailEnd type="none" w="med" len="med"/>
+                    </a:lnB>
+                  </a:tcPr>
+                </a:tc>
+                <a:tc>
+                  <a:txBody>
+                    <a:bodyPr/>
+                    <a:lstStyle/>
+                    <a:p>
+                      <a:pPr indent="0" marL="0">
+                        <a:buNone/>
+                      </a:pPr>
+                      <a:r>
+                        <a:rPr lang="en-US" sz="1200" dirty="0">
+                          <a:solidFill>
+                            <a:srgbClr val="1F2933"/>
+                          </a:solidFill>
+                          <a:latin typeface="Calibri" pitchFamily="34" charset="0"/>
+                          <a:ea typeface="Calibri" pitchFamily="34" charset="-122"/>
+                          <a:cs typeface="Calibri" pitchFamily="34" charset="-120"/>
+                        </a:rPr>
+                        <a:t>Ours comes down upright; stock flips</a:t>
+                      </a:r>
+                      <a:endParaRPr lang="en-US" sz="1200" dirty="0">
+                        <a:latin typeface="Calibri" charset="0"/>
+                        <a:ea typeface="Calibri" charset="0"/>
+                        <a:cs typeface="Calibri" charset="0"/>
+                      </a:endParaRPr>
+                    </a:p>
+                  </a:txBody>
+                  <a:tcPr marL="76200" marR="76200" marT="38100" marB="38100" anchor="ctr">
+                    <a:lnL w="9525" cap="flat" cmpd="sng" algn="ctr">
+                      <a:solidFill>
+                        <a:srgbClr val="C9D0D7"/>
+                      </a:solidFill>
+                      <a:prstDash val="solid"/>
+                      <a:round/>
+                      <a:headEnd type="none" w="med" len="med"/>
+                      <a:tailEnd type="none" w="med" len="med"/>
+                    </a:lnL>
+                    <a:lnR w="9525" cap="flat" cmpd="sng" algn="ctr">
+                      <a:solidFill>
+                        <a:srgbClr val="C9D0D7"/>
+                      </a:solidFill>
+                      <a:prstDash val="solid"/>
+                      <a:round/>
+                      <a:headEnd type="none" w="med" len="med"/>
+                      <a:tailEnd type="none" w="med" len="med"/>
+                    </a:lnR>
+                    <a:lnT w="9525" cap="flat" cmpd="sng" algn="ctr">
+                      <a:solidFill>
+                        <a:srgbClr val="C9D0D7"/>
+                      </a:solidFill>
+                      <a:prstDash val="solid"/>
+                      <a:round/>
+                      <a:headEnd type="none" w="med" len="med"/>
+                      <a:tailEnd type="none" w="med" len="med"/>
+                    </a:lnT>
+                    <a:lnB w="9525" cap="flat" cmpd="sng" algn="ctr">
+                      <a:solidFill>
+                        <a:srgbClr val="C9D0D7"/>
+                      </a:solidFill>
+                      <a:prstDash val="solid"/>
+                      <a:round/>
+                      <a:headEnd type="none" w="med" len="med"/>
+                      <a:tailEnd type="none" w="med" len="med"/>
+                    </a:lnB>
+                  </a:tcPr>
+                </a:tc>
+              </a:tr>
+            </a:tbl>
+          </a:graphicData>
+        </a:graphic>
+      </p:graphicFrame>
+      <p:sp>
+        <p:nvSpPr>
+          <p:cNvPr id="4" name="Text 1"/>
+          <p:cNvSpPr txBox="1"/>
+          <p:nvPr/>
+        </p:nvSpPr>
+        <p:spPr>
+          <a:xfrm>
+            <a:off x="457200" y="4462272"/>
+            <a:ext cx="8229600" cy="201168"/>
+          </a:xfrm>
+          <a:prstGeom prst="rect">
+            <a:avLst/>
+          </a:prstGeom>
+          <a:noFill/>
+          <a:ln/>
+        </p:spPr>
+        <p:txBody>
+          <a:bodyPr wrap="square" lIns="0" tIns="0" rIns="0" bIns="0" rtlCol="0" anchor="t"/>
+          <a:lstStyle/>
+          <a:p>
+            <a:pPr indent="0" marL="0">
+              <a:buNone/>
+            </a:pPr>
+            <a:r>
+              <a:rPr lang="en-US" sz="1000" dirty="0">
+                <a:solidFill>
+                  <a:schemeClr val="tx2"/>
+                </a:solidFill>
+              </a:rPr>
+              <a:t>CrazySim runs the real Crazyflie firmware with our controller in C. Next: thrust test, then staged flights on the real drone.</a:t>
+            </a:r>
+            <a:endParaRPr lang="en-US" sz="1000" dirty="0"/>
+          </a:p>
+        </p:txBody>
+      </p:sp>
+      <p:sp>
+        <p:nvSpPr>
+          <p:cNvPr id="25" name="Slide Number Placeholder 0"/>
+          <p:cNvSpPr>
+            <a:spLocks noGrp="1"/>
+          </p:cNvSpPr>
+          <p:nvPr>
+            <p:ph type="sldNum" sz="quarter" idx="4294967295"/>
+          </p:nvPr>
+        </p:nvSpPr>
+        <p:spPr>
+          <a:xfrm>
+            <a:off x="8229600" y="4754880"/>
+            <a:ext cx="457200" cy="228600"/>
+          </a:xfrm>
+          <a:prstGeom prst="rect">
+            <a:avLst/>
+          </a:prstGeom>
+          <a:extLst>
+            <a:ext uri="{C572A759-6A51-4108-AA02-DFA0A04FC94B}">
+              <ma14:wrappingTextBoxFlag xmlns:ma14="http://schemas.microsoft.com/office/mac/drawingml/2011/main" val="0"/>
+            </a:ext>
+          </a:extLst>
+        </p:spPr>
+        <p:txBody>
+          <a:bodyPr/>
+          <a:lstStyle>
+            <a:lvl1pPr>
+              <a:defRPr sz="900">
+                <a:solidFill>
+                  <a:schemeClr val="tx2"/>
+                </a:solidFill>
+              </a:defRPr>
+            </a:lvl1pPr>
+          </a:lstStyle>
+          <a:p>
+            <a:pPr algn="r"/>
+            <a:fld id="{F7021451-1387-4CA6-816F-3879F97B5CBC}" type="slidenum">
+              <a:rPr b="0" lang="en-US"/>
+              <a:t>12</a:t>
             </a:fld>
             <a:endParaRPr lang="en-US"/>
           </a:p>
@@ -10091,7 +12366,7 @@
                   <a:schemeClr val="accent1"/>
                 </a:solidFill>
               </a:rPr>
-              <a:t>2.2–3.5 : 1</a:t>
+              <a:t>1.7–2.2 : 1</a:t>
             </a:r>
             <a:endParaRPr lang="en-US" sz="4000" dirty="0"/>
           </a:p>
@@ -10127,7 +12402,7 @@
                   <a:schemeClr val="tx1"/>
                 </a:solidFill>
               </a:rPr>
-              <a:t>what our platform (Crazyflie) has</a:t>
+              <a:t>what a Crazyflie 2.1 has (27–29 g)</a:t>
             </a:r>
             <a:endParaRPr lang="en-US" sz="1400" dirty="0"/>
           </a:p>
@@ -10163,7 +12438,7 @@
                   <a:schemeClr val="tx2"/>
                 </a:solidFill>
               </a:rPr>
-              <a:t>2.1: ≈60 g thrust, 27 g</a:t>
+              <a:t>12.2 g per motor as rated by Bitcraze,</a:t>
             </a:r>
             <a:endParaRPr lang="en-US" sz="1100" dirty="0"/>
           </a:p>
@@ -10177,7 +12452,7 @@
                   <a:schemeClr val="tx2"/>
                 </a:solidFill>
               </a:rPr>
-              <a:t>Brushless: ≈120 g thrust, 34 g</a:t>
+              <a:t>up to ≈16 g on a full battery (to be measured)</a:t>
             </a:r>
             <a:endParaRPr lang="en-US" sz="1100" dirty="0"/>
           </a:p>
@@ -10202,6 +12477,10 @@
           </a:solidFill>
           <a:ln/>
         </p:spPr>
+        <p:txBody>
+          <a:bodyPr/>
+          <a:p/>
+        </p:txBody>
       </p:sp>
       <p:sp>
         <p:nvSpPr>
@@ -10269,7 +12548,7 @@
                   <a:schemeClr val="tx2"/>
                 </a:solidFill>
               </a:rPr>
-              <a:t>We give up heading control (yaw): the drone spins, while our controller keeps it level and on the path. This is the standard approach in fault-tolerant control research (Mueller &amp; D'Andrea; Sun et al.).</a:t>
+              <a:t>We give up heading control (yaw): the drone spins, while our controller keeps it level and on the path (Mueller &amp; D'Andrea; Sun et al.). It then has 2.5 motors' worth of thrust, so it needs at least 1.8 : 1 to keep flying: a Crazyflie 2.1 is at that limit, and below it the drone lands safely instead.</a:t>
             </a:r>
             <a:endParaRPr lang="en-US" sz="1400" dirty="0"/>
           </a:p>
@@ -10405,6 +12684,10 @@
             <a:prstDash val="solid"/>
           </a:ln>
         </p:spPr>
+        <p:txBody>
+          <a:bodyPr/>
+          <a:p/>
+        </p:txBody>
       </p:sp>
       <p:sp>
         <p:nvSpPr>
@@ -10428,6 +12711,10 @@
             <a:prstDash val="solid"/>
           </a:ln>
         </p:spPr>
+        <p:txBody>
+          <a:bodyPr/>
+          <a:p/>
+        </p:txBody>
       </p:sp>
       <p:sp>
         <p:nvSpPr>
@@ -10455,6 +12742,10 @@
             <a:prstDash val="solid"/>
           </a:ln>
         </p:spPr>
+        <p:txBody>
+          <a:bodyPr/>
+          <a:p/>
+        </p:txBody>
       </p:sp>
       <p:sp>
         <p:nvSpPr>
@@ -10480,6 +12771,10 @@
             <a:prstDash val="solid"/>
           </a:ln>
         </p:spPr>
+        <p:txBody>
+          <a:bodyPr/>
+          <a:p/>
+        </p:txBody>
       </p:sp>
       <p:sp>
         <p:nvSpPr>
@@ -10511,7 +12806,7 @@
                   <a:schemeClr val="tx1"/>
                 </a:solidFill>
               </a:rPr>
-              <a:t>9.75 g</a:t>
+              <a:t>10.4 g</a:t>
             </a:r>
             <a:endParaRPr lang="en-US" sz="1300" dirty="0"/>
           </a:p>
@@ -10555,6 +12850,10 @@
             <a:prstDash val="solid"/>
           </a:ln>
         </p:spPr>
+        <p:txBody>
+          <a:bodyPr/>
+          <a:p/>
+        </p:txBody>
       </p:sp>
       <p:sp>
         <p:nvSpPr>
@@ -10586,7 +12885,7 @@
                   <a:schemeClr val="tx1"/>
                 </a:solidFill>
               </a:rPr>
-              <a:t>3.75 g</a:t>
+              <a:t>3.1 g</a:t>
             </a:r>
             <a:endParaRPr lang="en-US" sz="1300" dirty="0"/>
           </a:p>
@@ -10630,6 +12929,10 @@
             <a:prstDash val="solid"/>
           </a:ln>
         </p:spPr>
+        <p:txBody>
+          <a:bodyPr/>
+          <a:p/>
+        </p:txBody>
       </p:sp>
       <p:sp>
         <p:nvSpPr>
@@ -10661,7 +12964,7 @@
                   <a:schemeClr val="tx1"/>
                 </a:solidFill>
               </a:rPr>
-              <a:t>3.75 g</a:t>
+              <a:t>3.1 g</a:t>
             </a:r>
             <a:endParaRPr lang="en-US" sz="1300" dirty="0"/>
           </a:p>
@@ -10705,6 +13008,10 @@
             <a:prstDash val="solid"/>
           </a:ln>
         </p:spPr>
+        <p:txBody>
+          <a:bodyPr/>
+          <a:p/>
+        </p:txBody>
       </p:sp>
       <p:sp>
         <p:nvSpPr>
@@ -10736,7 +13043,7 @@
                   <a:schemeClr val="tx1"/>
                 </a:solidFill>
               </a:rPr>
-              <a:t>9.75 g</a:t>
+              <a:t>10.4 g</a:t>
             </a:r>
             <a:endParaRPr lang="en-US" sz="1300" dirty="0"/>
           </a:p>
@@ -10800,7 +13107,7 @@
                   <a:schemeClr val="tx2"/>
                 </a:solidFill>
               </a:rPr>
-              <a:t>Hover needs 6.75 g per motor; max is 15 g.</a:t>
+              <a:t>Hover needs 6.75 g per motor; max is 12.2 g (Bitcraze rating).</a:t>
             </a:r>
             <a:endParaRPr lang="en-US" sz="1100" dirty="0"/>
           </a:p>
@@ -10872,7 +13179,7 @@
                   <a:schemeClr val="tx2"/>
                 </a:solidFill>
               </a:rPr>
-              <a:t>about 3.75 g, a quarter of its normal maximum</a:t>
+              <a:t>about 3.1 g, a quarter of its normal maximum</a:t>
             </a:r>
             <a:endParaRPr lang="en-US" sz="1300" dirty="0"/>
           </a:p>
@@ -11016,7 +13323,7 @@
                   <a:schemeClr val="tx2"/>
                 </a:solidFill>
               </a:rPr>
-              <a:t>9.75 g each, within their 15 g limit</a:t>
+              <a:t>10.4 g each: 86% of their 12.2 g limit, little left to steer</a:t>
             </a:r>
             <a:endParaRPr lang="en-US" sz="1300" dirty="0"/>
           </a:p>

</xml_diff>